<commit_message>
Correct viva/slides/dashboard to verified metrics; add safe scheduled refresh and real-browser PWA tests
- Viva guides, Beamer/PPTX decks, presentation README and Streamlit dashboard now use
  only figures from docs/VERIFIED_METRICS.md; withdrawn v1 claims removed (originals in 3926155).
  Stale PDF/previews replaced by a headless-compiled corrected Beamer PDF.
- py/agri/ops/refresh.py: locked, idempotent refresh with retries, staged release,
  validation, atomic symlink swap, status/history, alerts; API hot-reloads releases and
  reports refresh status. 12 tests, incl. a run-id collision bug they caught.
- tests/browser/pwa_e2e.mjs: headless Chrome (CDP) SW, installability, offline, throttled
  load, a11y and 6-language checks; CI browser job.
- Demo banner no longer calls real data 'examples'; journal/novelty analysis.

Co-Authored-By: Claude Opus 5.5 <noreply@anthropic.com>
</commit_message>
<xml_diff>
--- a/docs/presentation/Big_Data_Analytics_Final_Presentation.pptx
+++ b/docs/presentation/Big_Data_Analytics_Final_Presentation.pptx
@@ -1,25 +1,22 @@
 
 <file path=ppt/presentation.xml><?xml version="1.0" encoding="utf-8"?>
-<p:presentation xmlns:a="http://schemas.openxmlformats.org/drawingml/2006/main" xmlns:r="http://schemas.openxmlformats.org/officeDocument/2006/relationships" xmlns:p="http://schemas.openxmlformats.org/presentationml/2006/main" autoCompressPictures="0">
+<p:presentation xmlns:a="http://schemas.openxmlformats.org/drawingml/2006/main" xmlns:r="http://schemas.openxmlformats.org/officeDocument/2006/relationships" xmlns:p="http://schemas.openxmlformats.org/presentationml/2006/main" saveSubsetFonts="1" autoCompressPictures="0">
   <p:sldMasterIdLst>
     <p:sldMasterId id="2147483648" r:id="rId1"/>
   </p:sldMasterIdLst>
-  <p:notesMasterIdLst>
-    <p:notesMasterId r:id="rId4"/>
-  </p:notesMasterIdLst>
   <p:sldIdLst>
-    <p:sldId id="256" r:id="rId3"/>
-    <p:sldId id="257" r:id="rId5"/>
-    <p:sldId id="258" r:id="rId6"/>
-    <p:sldId id="259" r:id="rId7"/>
-    <p:sldId id="260" r:id="rId8"/>
-    <p:sldId id="261" r:id="rId9"/>
-    <p:sldId id="262" r:id="rId10"/>
-    <p:sldId id="263" r:id="rId11"/>
-    <p:sldId id="264" r:id="rId12"/>
-    <p:sldId id="265" r:id="rId13"/>
+    <p:sldId id="256" r:id="rId7"/>
+    <p:sldId id="257" r:id="rId9"/>
+    <p:sldId id="258" r:id="rId10"/>
+    <p:sldId id="259" r:id="rId11"/>
+    <p:sldId id="260" r:id="rId12"/>
+    <p:sldId id="261" r:id="rId13"/>
+    <p:sldId id="262" r:id="rId14"/>
+    <p:sldId id="263" r:id="rId15"/>
+    <p:sldId id="264" r:id="rId16"/>
+    <p:sldId id="265" r:id="rId17"/>
   </p:sldIdLst>
-  <p:sldSz cx="12191365" cy="6858000" type="screen4x3"/>
+  <p:sldSz cx="12191695" cy="6858000" type="screen4x3"/>
   <p:notesSz cx="6858000" cy="9144000"/>
   <p:defaultTextStyle>
     <a:defPPr>
@@ -116,27 +113,11 @@
       </a:defRPr>
     </a:lvl9pPr>
   </p:defaultTextStyle>
-  <p:extLst>
-    <p:ext uri="{EFAFB233-063F-42B5-8137-9DF3F51BA10A}">
-      <p15:sldGuideLst xmlns:p15="http://schemas.microsoft.com/office/powerpoint/2012/main">
-        <p15:guide id="1" orient="horz" pos="2160" userDrawn="1">
-          <p15:clr>
-            <a:srgbClr val="A4A3A4"/>
-          </p15:clr>
-        </p15:guide>
-        <p15:guide id="2" pos="2880" userDrawn="1">
-          <p15:clr>
-            <a:srgbClr val="A4A3A4"/>
-          </p15:clr>
-        </p15:guide>
-      </p15:sldGuideLst>
-    </p:ext>
-  </p:extLst>
 </p:presentation>
 </file>
 
 <file path=ppt/notesMasters/notesMaster1.xml><?xml version="1.0" encoding="utf-8"?>
-<p:notesMaster xmlns:a="http://schemas.openxmlformats.org/drawingml/2006/main" xmlns:r="http://schemas.openxmlformats.org/officeDocument/2006/relationships" xmlns:p="http://schemas.openxmlformats.org/presentationml/2006/main">
+<p:notesMaster xmlns:a="http://schemas.openxmlformats.org/drawingml/2006/main" xmlns:p="http://schemas.openxmlformats.org/presentationml/2006/main" xmlns:r="http://schemas.openxmlformats.org/officeDocument/2006/relationships">
   <p:cSld>
     <p:bg>
       <p:bgRef idx="1001">
@@ -217,6 +198,7 @@
           <a:p>
             <a:fld id="{0F89C1C7-3DCD-1040-A9CF-14679D8B5DDD}" type="datetimeFigureOut">
               <a:rPr lang="en-US" smtClean="0"/>
+              <a:t>10/17/16</a:t>
             </a:fld>
             <a:endParaRPr lang="en-US"/>
           </a:p>
@@ -283,7 +265,6 @@
               <a:rPr lang="en-US" smtClean="0"/>
               <a:t>Click to edit Master text styles</a:t>
             </a:r>
-            <a:endParaRPr lang="en-US" smtClean="0"/>
           </a:p>
           <a:p>
             <a:pPr lvl="1"/>
@@ -291,7 +272,6 @@
               <a:rPr lang="en-US" smtClean="0"/>
               <a:t>Second level</a:t>
             </a:r>
-            <a:endParaRPr lang="en-US" smtClean="0"/>
           </a:p>
           <a:p>
             <a:pPr lvl="2"/>
@@ -299,7 +279,6 @@
               <a:rPr lang="en-US" smtClean="0"/>
               <a:t>Third level</a:t>
             </a:r>
-            <a:endParaRPr lang="en-US" smtClean="0"/>
           </a:p>
           <a:p>
             <a:pPr lvl="3"/>
@@ -307,7 +286,6 @@
               <a:rPr lang="en-US" smtClean="0"/>
               <a:t>Fourth level</a:t>
             </a:r>
-            <a:endParaRPr lang="en-US" smtClean="0"/>
           </a:p>
           <a:p>
             <a:pPr lvl="4"/>
@@ -379,12 +357,18 @@
           <a:p>
             <a:fld id="{BB5E49A5-4136-284D-997B-48E1D791AD67}" type="slidenum">
               <a:rPr lang="en-US" smtClean="0"/>
+              <a:t>‹#›</a:t>
             </a:fld>
             <a:endParaRPr lang="en-US"/>
           </a:p>
         </p:txBody>
       </p:sp>
     </p:spTree>
+    <p:extLst>
+      <p:ext uri="{BB962C8B-B14F-4D97-AF65-F5344CB8AC3E}">
+        <p14:creationId xmlns:p14="http://schemas.microsoft.com/office/powerpoint/2010/main" val="2623252185"/>
+      </p:ext>
+    </p:extLst>
   </p:cSld>
   <p:clrMap bg1="lt1" tx1="dk1" bg2="lt2" tx2="dk2" accent1="accent1" accent2="accent2" accent3="accent3" accent4="accent4" accent5="accent5" accent6="accent6" hlink="hlink" folHlink="folHlink"/>
   <p:notesStyle>
@@ -483,7 +467,7 @@
 </file>
 
 <file path=ppt/notesSlides/notesSlide1.xml><?xml version="1.0" encoding="utf-8"?>
-<p:notes xmlns:a="http://schemas.openxmlformats.org/drawingml/2006/main" xmlns:r="http://schemas.openxmlformats.org/officeDocument/2006/relationships" xmlns:p="http://schemas.openxmlformats.org/presentationml/2006/main">
+<p:notes xmlns:a="http://schemas.openxmlformats.org/drawingml/2006/main" xmlns:p="http://schemas.openxmlformats.org/presentationml/2006/main" xmlns:r="http://schemas.openxmlformats.org/officeDocument/2006/relationships">
   <p:cSld>
     <p:spTree>
       <p:nvGrpSpPr>
@@ -518,7 +502,7 @@
             <a:spLocks noGrp="1"/>
           </p:cNvSpPr>
           <p:nvPr>
-            <p:ph type="body" sz="quarter" idx="3"/>
+            <p:ph type="body" idx="3" sz="quarter"/>
           </p:nvPr>
         </p:nvSpPr>
         <p:spPr/>
@@ -532,7 +516,7 @@
           </a:p>
           <a:p>
             <a:r>
-              <a:t>Good morning Dr. Sreeja and evaluators. Today, our team presents our Big Data Analytics final project: Agricultural Commodity Price Forecasting and Market Analysis using Hadoop HDFS and Apache Spark. Our team members are Rishitha, Karthikeya, Ashwin, and Kaushal. The goal of this project is to build an end-to-end distributed data engineering and analytics pipeline capable of processing 132.86 million real agricultural market records, detecting price anomalies with machine learning, and streaming market alerts in real time.</a:t>
+              <a:t>Good morning Dr. Sreeja and evaluators. Today, our team presents our Big Data Analytics final project: Agricultural Commodity Price Forecasting and Market Analysis using Hadoop HDFS and Apache Spark. Our team members are Rishitha, Karthikeya, Ashwin, and Kaushal. The goal of this project is an end-to-end distributed pipeline over 75.98 million archived mandi reports plus 7.7 million official records that forecasts mandi prices 1 to 14 days ahead with Spark MLlib, with measured 80% intervals, and streams daily reports through Kafka.</a:t>
             </a:r>
           </a:p>
           <a:p/>
@@ -565,7 +549,7 @@
           </a:p>
           <a:p>
             <a:r>
-              <a:t>Ma'am, our core focus is distributed data architecture: distributed storage using HDFS replication, scalable in-memory feature engineering and deduplication in Apache Spark, machine learning using Spark MLlib, and real-time micro-batch processing using Apache Kafka.</a:t>
+              <a:t>Ma'am, our core focus is distributed data architecture: distributed storage using HDFS replication, leakage-safe feature engineering and deduplication in Apache Spark, honestly evaluated price forecasting with Spark MLlib, and micro-batch processing of daily reports through Kafka and Structured Streaming.</a:t>
             </a:r>
           </a:p>
         </p:txBody>
@@ -577,7 +561,7 @@
             <a:spLocks noGrp="1"/>
           </p:cNvSpPr>
           <p:nvPr>
-            <p:ph type="sldNum" sz="quarter" idx="5"/>
+            <p:ph type="sldNum" idx="5" sz="quarter"/>
           </p:nvPr>
         </p:nvSpPr>
         <p:spPr/>
@@ -591,7 +575,7 @@
 </file>
 
 <file path=ppt/notesSlides/notesSlide10.xml><?xml version="1.0" encoding="utf-8"?>
-<p:notes xmlns:a="http://schemas.openxmlformats.org/drawingml/2006/main" xmlns:r="http://schemas.openxmlformats.org/officeDocument/2006/relationships" xmlns:p="http://schemas.openxmlformats.org/presentationml/2006/main">
+<p:notes xmlns:a="http://schemas.openxmlformats.org/drawingml/2006/main" xmlns:p="http://schemas.openxmlformats.org/presentationml/2006/main" xmlns:r="http://schemas.openxmlformats.org/officeDocument/2006/relationships">
   <p:cSld>
     <p:spTree>
       <p:nvGrpSpPr>
@@ -626,7 +610,7 @@
             <a:spLocks noGrp="1"/>
           </p:cNvSpPr>
           <p:nvPr>
-            <p:ph type="body" sz="quarter" idx="3"/>
+            <p:ph type="body" idx="3" sz="quarter"/>
           </p:nvPr>
         </p:nvSpPr>
         <p:spPr/>
@@ -640,7 +624,7 @@
           </a:p>
           <a:p>
             <a:r>
-              <a:t>Finally, Slide 10 provides our authoritative technical references and project deliverables. Our repository is public at `https://github.com/kaushalrog/AG-DATA`. It contains complete Scala pipelines, Docker configurations, Kafka streaming scripts, and our Streamlit dashboard. Our work is grounded in authoritative literature from Apache Spark, Apache Hadoop, and the Ministry of Agriculture. This concludes our presentation, and our team is now ready for your questions. Thank you, Dr. Sreeja.</a:t>
+              <a:t>Finally, Slide 10 provides our authoritative technical references and project deliverables. Our repository is public at `https://github.com/kaushalrog/AG-DATA`. It contains the Scala pipelines, Docker configurations, Kafka streaming scripts, the API and the six-language app. Our work is grounded in authoritative literature from Apache Spark, Apache Hadoop, and the Ministry of Agriculture. Every number we quoted is listed with its source in docs/VERIFIED_METRICS.md. This concludes our presentation, and our team is now ready for your questions. Thank you, Dr. Sreeja.</a:t>
             </a:r>
           </a:p>
           <a:p/>
@@ -673,7 +657,7 @@
           </a:p>
           <a:p>
             <a:r>
-              <a:t>Ma'am, in our GitHub repository under `results/` and `docs/VIVA_EVIDENCE.md`, where all execution logs, checksums, confusion matrices, and audit runs are documented.</a:t>
+              <a:t>Ma'am, in our GitHub repository: docs/VERIFIED_METRICS.md lists every number with its source file under results/ (forecast metrics, intervals, DM tests, anomaly benchmark, streaming summary, HDFS checks), and docs/AUDIT_PRIOR_RESULTS.md documents the withdrawn v1 claims.</a:t>
             </a:r>
           </a:p>
         </p:txBody>
@@ -685,7 +669,7 @@
             <a:spLocks noGrp="1"/>
           </p:cNvSpPr>
           <p:nvPr>
-            <p:ph type="sldNum" sz="quarter" idx="5"/>
+            <p:ph type="sldNum" idx="5" sz="quarter"/>
           </p:nvPr>
         </p:nvSpPr>
         <p:spPr/>
@@ -699,7 +683,7 @@
 </file>
 
 <file path=ppt/notesSlides/notesSlide2.xml><?xml version="1.0" encoding="utf-8"?>
-<p:notes xmlns:a="http://schemas.openxmlformats.org/drawingml/2006/main" xmlns:r="http://schemas.openxmlformats.org/officeDocument/2006/relationships" xmlns:p="http://schemas.openxmlformats.org/presentationml/2006/main">
+<p:notes xmlns:a="http://schemas.openxmlformats.org/drawingml/2006/main" xmlns:p="http://schemas.openxmlformats.org/presentationml/2006/main" xmlns:r="http://schemas.openxmlformats.org/officeDocument/2006/relationships">
   <p:cSld>
     <p:spTree>
       <p:nvGrpSpPr>
@@ -734,7 +718,7 @@
             <a:spLocks noGrp="1"/>
           </p:cNvSpPr>
           <p:nvPr>
-            <p:ph type="body" sz="quarter" idx="3"/>
+            <p:ph type="body" idx="3" sz="quarter"/>
           </p:nvPr>
         </p:nvSpPr>
         <p:spPr/>
@@ -748,7 +732,7 @@
           </a:p>
           <a:p>
             <a:r>
-              <a:t>Slide 2 defines what we are trying to find. On the left, we look for unusual mandi price fluctuations: identifying sudden price spikes or crashes that distort wholesale trading. On the right, our domain motivation is farmer decision support: providing actionable guidance such as SELL before a glut, or HOLD during an artificial panic. In the bottom callout box, we address why Big Data tools are needed: with over 132 million records, single-node tools like Pandas exhaust memory. HDFS stores the data across replicated blocks, while Spark distributes the feature engineering and MLlib computations across CPU cores.</a:t>
+              <a:t>Slide 2 defines what we are trying to find. On the left: the modal price a mandi will report 1, 3, 7 and 14 days ahead, for 36 commodities and 11,845 series, each with an 80% interval. We always compare with persistence, the last reported price, which is hard to beat because 17 to 34% of price changes are exactly zero. On the right, the forecasts become cautious SELL, HOLD, WATCH and COMPARE cards. In the bottom box: 75.98 million reports and 21.06 million feature rows do not fit single-node Pandas, so HDFS stores the data in replicated blocks and Spark distributes the feature engineering and MLlib work across CPU cores.</a:t>
             </a:r>
           </a:p>
           <a:p/>
@@ -781,7 +765,7 @@
           </a:p>
           <a:p>
             <a:r>
-              <a:t>Ma'am, executing 7-day rolling window aggregations and composite deduplication across 132 million records causes single-node systems to run out of memory. Spark provides Catalyst query optimization, off-heap Tungsten execution, and partition-level parallelism that can scale to hundreds of millions of records.</a:t>
+              <a:t>Ma'am, per-series window features and business-key deduplication over 75 million reports exceed the memory of a single-node tool on our 16 GB laptop. Spark provides Catalyst query optimization, Tungsten execution and partition-level parallelism; on the full 75.6 million rows, 10 cores give a 2.4 to 3.0 times speed-up over one core.</a:t>
             </a:r>
           </a:p>
         </p:txBody>
@@ -793,7 +777,7 @@
             <a:spLocks noGrp="1"/>
           </p:cNvSpPr>
           <p:nvPr>
-            <p:ph type="sldNum" sz="quarter" idx="5"/>
+            <p:ph type="sldNum" idx="5" sz="quarter"/>
           </p:nvPr>
         </p:nvSpPr>
         <p:spPr/>
@@ -807,7 +791,7 @@
 </file>
 
 <file path=ppt/notesSlides/notesSlide3.xml><?xml version="1.0" encoding="utf-8"?>
-<p:notes xmlns:a="http://schemas.openxmlformats.org/drawingml/2006/main" xmlns:r="http://schemas.openxmlformats.org/officeDocument/2006/relationships" xmlns:p="http://schemas.openxmlformats.org/presentationml/2006/main">
+<p:notes xmlns:a="http://schemas.openxmlformats.org/drawingml/2006/main" xmlns:p="http://schemas.openxmlformats.org/presentationml/2006/main" xmlns:r="http://schemas.openxmlformats.org/officeDocument/2006/relationships">
   <p:cSld>
     <p:spTree>
       <p:nvGrpSpPr>
@@ -842,7 +826,7 @@
             <a:spLocks noGrp="1"/>
           </p:cNvSpPr>
           <p:nvPr>
-            <p:ph type="body" sz="quarter" idx="3"/>
+            <p:ph type="body" idx="3" sz="quarter"/>
           </p:nvPr>
         </p:nvSpPr>
         <p:spPr/>
@@ -856,7 +840,7 @@
           </a:p>
           <a:p>
             <a:r>
-              <a:t>Slide 3 presents our datasets and the 5 Vs of Big Data. On the left, we detail the data stored in HDFS: Daily Market Prices has 75.98 million rows, and India Mandi has 56.88 million rows, giving 132.86 million raw records. Quality filtering isolates 93.41 million clean canonical records for feature engineering. On the right, the 5 Vs map directly to our project: Volume is 10.9 GB raw CSV scaled to ~18 GB; Velocity is streaming micro-batches via Kafka; Variety spans 351 CSV files with differing date schemas; Veracity filters 535,000 duplicate records; and Value delivers actionable price anomaly warnings. As highlighted at the bottom, all ML models were trained and tested strictly on genuine real data.</a:t>
+              <a:t>Slide 3 presents our data layers and the 5 Vs. The raw archive has 75.98 million rows; after quality rules and de-duplication the silver layer keeps 75.64 million. We back-filled 7.72 million official records from data.gov.in for October 2025 to October 2026, giving a silver v2 layer of 82.1 million rows. The back-fill showed that the archive mirror holds only 30% of official reports after September 2025. The forecast panel has 21.06 million feature rows over 11,845 series. On the right, the 5 Vs map to our project. All models are trained and tested on real data only.</a:t>
             </a:r>
           </a:p>
           <a:p/>
@@ -878,7 +862,7 @@
           </a:p>
           <a:p>
             <a:r>
-              <a:t>Why is there a difference between the 132.8M raw rows and the 93.4M canonical rows?</a:t>
+              <a:t>Why does silver v2 differ from the archive silver layer?</a:t>
             </a:r>
           </a:p>
           <a:p/>
@@ -889,7 +873,7 @@
           </a:p>
           <a:p>
             <a:r>
-              <a:t>Ma'am, 132.8 million is the total raw rows ingested from disk. When we remove 535,261 duplicate transactions and filter out records with zero prices or negative spreads (Max &lt; Min), 93.41 million verified, clean canonical records remain in HDFS for feature engineering.</a:t>
+              <a:t>Ma'am, the archive silver layer has 75.64 million rows. Silver v2 keeps the archive before 2025-10-01 (74.49 million rows) and replaces everything from 2025-10-01 with the official data.gov.in back-fill (7.63 million rows after the same rules), giving 82.11 million rows. We did this because the archive mirror holds only 30% of the official reports for that period.</a:t>
             </a:r>
           </a:p>
         </p:txBody>
@@ -901,7 +885,7 @@
             <a:spLocks noGrp="1"/>
           </p:cNvSpPr>
           <p:nvPr>
-            <p:ph type="sldNum" sz="quarter" idx="5"/>
+            <p:ph type="sldNum" idx="5" sz="quarter"/>
           </p:nvPr>
         </p:nvSpPr>
         <p:spPr/>
@@ -915,7 +899,7 @@
 </file>
 
 <file path=ppt/notesSlides/notesSlide4.xml><?xml version="1.0" encoding="utf-8"?>
-<p:notes xmlns:a="http://schemas.openxmlformats.org/drawingml/2006/main" xmlns:r="http://schemas.openxmlformats.org/officeDocument/2006/relationships" xmlns:p="http://schemas.openxmlformats.org/presentationml/2006/main">
+<p:notes xmlns:a="http://schemas.openxmlformats.org/drawingml/2006/main" xmlns:p="http://schemas.openxmlformats.org/presentationml/2006/main" xmlns:r="http://schemas.openxmlformats.org/officeDocument/2006/relationships">
   <p:cSld>
     <p:spTree>
       <p:nvGrpSpPr>
@@ -950,7 +934,7 @@
             <a:spLocks noGrp="1"/>
           </p:cNvSpPr>
           <p:nvPr>
-            <p:ph type="body" sz="quarter" idx="3"/>
+            <p:ph type="body" idx="3" sz="quarter"/>
           </p:nvPr>
         </p:nvSpPr>
         <p:spPr/>
@@ -964,7 +948,7 @@
           </a:p>
           <a:p>
             <a:r>
-              <a:t>Slide 4 details our System Setup and Configuration. Across the top is our end-to-end pipeline: raw CSV inputs pass to HDFS for block storage, Scala readers clean and deduplicate data, Spark computes rolling window features and MLlib models, and results feed the live dashboard. On the middle left, HDFS runs 1 NameNode and 3 DataNodes in Docker with 128 MB blocks and replication factor 3. On the middle right, Spark executes in local[*] mode using local multi-core threads. The bottom callout box directly answers a frequent viva question: our HDFS DataNodes store the data blocks, but they are not Spark compute executors.</a:t>
+              <a:t>Slide 4 details our System Setup and Configuration. Across the top is our end-to-end pipeline: archive CSVs and official API records are cleaned and de-duplicated by Scala readers, stored as Parquet layers in HDFS, Spark computes leakage-safe features and MLlib forecasts, and gold tables feed the API and the six-language app. On the middle left, HDFS runs 1 NameNode and 3 DataNodes in Docker with 128 MB blocks and replication factor 3; the 692 MB silver layer is HEALTHY and stayed readable with one DataNode down. On the middle right, Spark executes in local[*] mode on 10 cores with 64 shuffle partitions. The bottom box answers a frequent viva question: DataNodes store blocks, they are not Spark executors.</a:t>
             </a:r>
           </a:p>
           <a:p/>
@@ -997,7 +981,7 @@
           </a:p>
           <a:p>
             <a:r>
-              <a:t>Ma'am, we wanted to be academically transparent. Running multi-container HDFS on Docker provides genuine distributed block storage, replication, and failover. Executing Spark in `local[*]` mode efficiently leverages multi-core CPU parallelism without claiming unverified multi-node physical rack infrastructure.</a:t>
+              <a:t>Ma'am, we only had one machine, and we wanted to be transparent. Multi-container HDFS on Docker gives genuine block storage, replication and failover behaviour. Spark in local[*] mode uses all 10 cores; we also ran a 2-worker Docker Spark cluster on the same host (11.27 million rows: 9.2 s and 14.4 s for our two workloads). We do not claim a physical multi-node cluster.</a:t>
             </a:r>
           </a:p>
         </p:txBody>
@@ -1009,7 +993,7 @@
             <a:spLocks noGrp="1"/>
           </p:cNvSpPr>
           <p:nvPr>
-            <p:ph type="sldNum" sz="quarter" idx="5"/>
+            <p:ph type="sldNum" idx="5" sz="quarter"/>
           </p:nvPr>
         </p:nvSpPr>
         <p:spPr/>
@@ -1023,7 +1007,7 @@
 </file>
 
 <file path=ppt/notesSlides/notesSlide5.xml><?xml version="1.0" encoding="utf-8"?>
-<p:notes xmlns:a="http://schemas.openxmlformats.org/drawingml/2006/main" xmlns:r="http://schemas.openxmlformats.org/officeDocument/2006/relationships" xmlns:p="http://schemas.openxmlformats.org/presentationml/2006/main">
+<p:notes xmlns:a="http://schemas.openxmlformats.org/drawingml/2006/main" xmlns:p="http://schemas.openxmlformats.org/presentationml/2006/main" xmlns:r="http://schemas.openxmlformats.org/officeDocument/2006/relationships">
   <p:cSld>
     <p:spTree>
       <p:nvGrpSpPr>
@@ -1058,7 +1042,7 @@
             <a:spLocks noGrp="1"/>
           </p:cNvSpPr>
           <p:nvPr>
-            <p:ph type="body" sz="quarter" idx="3"/>
+            <p:ph type="body" idx="3" sz="quarter"/>
           </p:nvPr>
         </p:nvSpPr>
         <p:spPr/>
@@ -1072,7 +1056,7 @@
           </a:p>
           <a:p>
             <a:r>
-              <a:t>Slide 5 covers Spark Workflow and DAG execution. On the left, we walk through our execution steps: reading explicit schemas, map-side composite deduplication, 7-day rolling window calculations, and MLlib model training. We partition across 200 shuffle partitions and leverage year directory pruning. On the right, the DAG diagram shows how Spark schedules tasks: narrow transformations pipeline in memory, while wide transformations like Window.partitionBy trigger shuffles that divide the DAG into distinct stages. In our feature engineering run, Spark completed across 13 stages. In the bottom box, we explain that stage boundaries are determined by shuffle dependencies, not hardcoded in code.</a:t>
+              <a:t>Slide 5 covers Spark Workflow and DAG execution. On the left are our steps: explicit schemas, quality rules and business-key de-duplication, leakage-safe window features and targets, and MLlib model fitting and scoring. We use 64 shuffle partitions, coalesced by AQE, and year directory pruning. On the full 75.6 million rows, 10 cores give a 2.4 to 3.0 times speed-up over one core. On the right, the DAG diagram shows how Spark schedules work: narrow transformations pipeline in memory, while wide transformations like Window.partitionBy trigger shuffles that divide the DAG into stages. The bottom box explains that stage boundaries come from shuffle dependencies; we read the exact counts in the Spark UI.</a:t>
             </a:r>
           </a:p>
           <a:p/>
@@ -1117,7 +1101,7 @@
             <a:spLocks noGrp="1"/>
           </p:cNvSpPr>
           <p:nvPr>
-            <p:ph type="sldNum" sz="quarter" idx="5"/>
+            <p:ph type="sldNum" idx="5" sz="quarter"/>
           </p:nvPr>
         </p:nvSpPr>
         <p:spPr/>
@@ -1131,7 +1115,7 @@
 </file>
 
 <file path=ppt/notesSlides/notesSlide6.xml><?xml version="1.0" encoding="utf-8"?>
-<p:notes xmlns:a="http://schemas.openxmlformats.org/drawingml/2006/main" xmlns:r="http://schemas.openxmlformats.org/officeDocument/2006/relationships" xmlns:p="http://schemas.openxmlformats.org/presentationml/2006/main">
+<p:notes xmlns:a="http://schemas.openxmlformats.org/drawingml/2006/main" xmlns:p="http://schemas.openxmlformats.org/presentationml/2006/main" xmlns:r="http://schemas.openxmlformats.org/officeDocument/2006/relationships">
   <p:cSld>
     <p:spTree>
       <p:nvGrpSpPr>
@@ -1166,7 +1150,7 @@
             <a:spLocks noGrp="1"/>
           </p:cNvSpPr>
           <p:nvPr>
-            <p:ph type="body" sz="quarter" idx="3"/>
+            <p:ph type="body" idx="3" sz="quarter"/>
           </p:nvPr>
         </p:nvSpPr>
         <p:spPr/>
@@ -1180,7 +1164,7 @@
           </a:p>
           <a:p>
             <a:r>
-              <a:t>Slide 6 presents our Scala implementation and streaming architecture. On the left are actual production excerpts from our codebase: snippet 1 uses coalesce with try_to_date across both date formats, preventing corrupt rows from terminating long-running batch jobs; snippet 2 performs map-side business key deduplication over a 7-column composite key; and snippet 3 shows stateful streaming using flatMapGroupsWithState. On the right, we summarize the concrete benefits. The bottom box explains our Kafka streaming: we replay 15,000 real market events, consume them in Spark Structured Streaming, update stateful rolling windows, and write prediction checkpoints directly into HDFS.</a:t>
+              <a:t>Slide 6 presents our Scala implementation and streaming architecture. On the left are excerpts from our codebase: snippet 1 uses try_to_date so a malformed date becomes null instead of failing the job; snippet 2 de-duplicates deterministically over the business key with row_number; snippet 3 builds a feature window that ends at the current report, which our perturbation test enforces. The bottom box explains streaming: reports go through Kafka topic agri.prices.v1 into PriceEventStream, which writes bronze, quarantines invalid messages before the watermark, removes re-sends and writes silver and alerts. In our replay, 21,524 messages gave 20,000 rows in silver, 1,317 duplicates removed and 207 quarantined, with nothing missing.</a:t>
             </a:r>
           </a:p>
           <a:p/>
@@ -1202,7 +1186,7 @@
           </a:p>
           <a:p>
             <a:r>
-              <a:t>Why use flatMapGroupsWithState instead of standard windowing in streaming?</a:t>
+              <a:t>Why don't you compute forecast features in the stream?</a:t>
             </a:r>
           </a:p>
           <a:p/>
@@ -1213,7 +1197,7 @@
           </a:p>
           <a:p>
             <a:r>
-              <a:t>Ma'am, standard streaming windowing requires micro-batch tumbling or sliding event-time windows with watermarking. In our application, mandi arrival events arrive irregularly per market; `flatMapGroupsWithState` allows us to maintain a custom, stateful 7-observation rolling buffer per `MarketEntity` across arbitrarily spaced arrivals.</a:t>
+              <a:t>Ma'am, it was a deliberate trade-off: one feature implementation instead of two that could drift apart. Streaming validates reports and raises alerts; features and forecasts are recomputed by the daily batch job. Batch and stream share the same canonicalisation code, and our parity check found 0 mismatches between them.</a:t>
             </a:r>
           </a:p>
         </p:txBody>
@@ -1225,7 +1209,7 @@
             <a:spLocks noGrp="1"/>
           </p:cNvSpPr>
           <p:nvPr>
-            <p:ph type="sldNum" sz="quarter" idx="5"/>
+            <p:ph type="sldNum" idx="5" sz="quarter"/>
           </p:nvPr>
         </p:nvSpPr>
         <p:spPr/>
@@ -1239,7 +1223,7 @@
 </file>
 
 <file path=ppt/notesSlides/notesSlide7.xml><?xml version="1.0" encoding="utf-8"?>
-<p:notes xmlns:a="http://schemas.openxmlformats.org/drawingml/2006/main" xmlns:r="http://schemas.openxmlformats.org/officeDocument/2006/relationships" xmlns:p="http://schemas.openxmlformats.org/presentationml/2006/main">
+<p:notes xmlns:a="http://schemas.openxmlformats.org/drawingml/2006/main" xmlns:p="http://schemas.openxmlformats.org/presentationml/2006/main" xmlns:r="http://schemas.openxmlformats.org/officeDocument/2006/relationships">
   <p:cSld>
     <p:spTree>
       <p:nvGrpSpPr>
@@ -1274,7 +1258,7 @@
             <a:spLocks noGrp="1"/>
           </p:cNvSpPr>
           <p:nvPr>
-            <p:ph type="body" sz="quarter" idx="3"/>
+            <p:ph type="body" idx="3" sz="quarter"/>
           </p:nvPr>
         </p:nvSpPr>
         <p:spPr/>
@@ -1288,7 +1272,7 @@
           </a:p>
           <a:p>
             <a:r>
-              <a:t>Slide 7 explains our model training and testing methodology. On the left, we clearly distinguish our two models: Task A is Next-Day Anomaly Forecasting, which predicts tomorrow's price spike; Task B is Real-Time Transaction Screening, which evaluates current transactions in Kafka. Both utilize Spark MLlib Random Forest with 100 trees. On the right, we highlight our strict temporal split: training on pre-2024 data, tuning on 2024 validation data, and testing on untouched 2025+ records. The bottom callout box emphasizes zero data leakage: random splits leak future trends into past training, but chronological splitting accurately simulates real-world production.</a:t>
+              <a:t>Slide 7 explains how we train and test. On the left: persistence, moving-average and seasonal-naive baselines against MLlib linear regression, random forests and gradient-boosted trees, one global model per horizon. Absolute-loss GBT was selected for next and 3 days, random forest for 7 and 14 days. On the right: train origins 2016 to 2023, model choice and conformal calibration on 2024, and the January 2025 to April 2026 test scored once. We then re-scored the frozen models on complete official data and on six months, April to October 2026, that did not exist in the archive. The bottom box explains why random splits would leak future information.</a:t>
             </a:r>
           </a:p>
           <a:p/>
@@ -1310,7 +1294,7 @@
           </a:p>
           <a:p>
             <a:r>
-              <a:t>Why does Task B achieve 95.66% accuracy while Task A achieves 85% accuracy?</a:t>
+              <a:t>Why did you replace the v1 anomaly classifier with forecasting?</a:t>
             </a:r>
           </a:p>
           <a:p/>
@@ -1321,7 +1305,7 @@
           </a:p>
           <a:p>
             <a:r>
-              <a:t>Ma'am, Task A is predictive forecasting: predicting tomorrow's market outcome given only today's data, which carries inherent market uncertainty. Task B is real-time anomaly classification: evaluating whether the current transaction is anomalous given contemporaneous price spreads. Task B is designed for real-time Kafka transaction screening, whereas Task A is a predictive forecasting problem.</a:t>
+              <a:t>Ma'am, we audited v1 and found its headline classifier metrics were not produced by any code or log, its labels were functions of its own features, and its outlier bounds were fitted on the test years; its only logged classifier (72.54% accuracy) was below the 84.35% all-normal baseline. Those claims are withdrawn (docs/AUDIT_PRIOR_RESULTS.md). The project title promises price forecasting, so we built an honest forecasting benchmark instead.</a:t>
             </a:r>
           </a:p>
         </p:txBody>
@@ -1333,7 +1317,7 @@
             <a:spLocks noGrp="1"/>
           </p:cNvSpPr>
           <p:nvPr>
-            <p:ph type="sldNum" sz="quarter" idx="5"/>
+            <p:ph type="sldNum" idx="5" sz="quarter"/>
           </p:nvPr>
         </p:nvSpPr>
         <p:spPr/>
@@ -1347,7 +1331,7 @@
 </file>
 
 <file path=ppt/notesSlides/notesSlide8.xml><?xml version="1.0" encoding="utf-8"?>
-<p:notes xmlns:a="http://schemas.openxmlformats.org/drawingml/2006/main" xmlns:r="http://schemas.openxmlformats.org/officeDocument/2006/relationships" xmlns:p="http://schemas.openxmlformats.org/presentationml/2006/main">
+<p:notes xmlns:a="http://schemas.openxmlformats.org/drawingml/2006/main" xmlns:p="http://schemas.openxmlformats.org/presentationml/2006/main" xmlns:r="http://schemas.openxmlformats.org/officeDocument/2006/relationships">
   <p:cSld>
     <p:spTree>
       <p:nvGrpSpPr>
@@ -1382,7 +1366,7 @@
             <a:spLocks noGrp="1"/>
           </p:cNvSpPr>
           <p:nvPr>
-            <p:ph type="body" sz="quarter" idx="3"/>
+            <p:ph type="body" idx="3" sz="quarter"/>
           </p:nvPr>
         </p:nvSpPr>
         <p:spPr/>
@@ -1396,7 +1380,7 @@
           </a:p>
           <a:p>
             <a:r>
-              <a:t>Slide 8 presents our verified empirical results. The top table compares all models against the trivial All-Normal baseline. Our Task 2 production screening model achieves 95.66% accuracy, 86.55% precision, 85.47% recall, and an 86.01% F1-score with a 2.46% false alarm rate. On the bottom left, we explain what this means: 86.55% precision ensures alerts are actionable, and a 2.46% FPR prevents false panic. On the bottom right, our 15,000-record Kafka replay demonstrates pipeline throughput of 1,200 events per second with sub-800ms micro-batch latency, validating our distributed streaming infrastructure.</a:t>
+              <a:t>Slide 8 presents our verified results. The top table shows relative MAE against persistence on the 2025 to 2026 test: 0.971, 0.953, 0.938 and 0.923 for next, 3, 7 and 14 days, with 80% intervals covering 78.6 to 80.5%. The last column shows the frozen models on six unseen months: 0.952 to 0.963. Every Diebold–Mariano p-value is at most 1.3e-22. On the bottom left: the gains are modest but hold on most series; decision cards are conservative; anomaly flags are evaluated only on injected corruptions. On the bottom right: the Kafka replay delivered all 20,000 valid messages with 0 parity mismatches and a 1.69 second median latency, and HDFS stayed readable with one DataNode down.</a:t>
             </a:r>
           </a:p>
           <a:p/>
@@ -1418,7 +1402,7 @@
           </a:p>
           <a:p>
             <a:r>
-              <a:t>How do you know the model didn't just memorize the majority class?</a:t>
+              <a:t>Your model beats 'last price' by only 3 to 8%. Why so small, and is it real?</a:t>
             </a:r>
           </a:p>
           <a:p/>
@@ -1429,7 +1413,7 @@
           </a:p>
           <a:p>
             <a:r>
-              <a:t>Ma'am, an 'All-Normal' model predicting zero anomalies gets 84.35% accuracy, but 0% recall and 0% precision. Our tuned model achieves 86.55% precision, 85.47% recall, and an ROC-AUC of 94.82%. Both precision and recall exceed 85%, proving the model genuinely identifies anomalies.</a:t>
+              <a:t>Ma'am, persistence is a hard baseline for mandi prices: 17 to 34% of price changes are exactly zero because mandis re-quote prices. The gain is real: Diebold–Mariano tests reject equal accuracy at every horizon, the model beats persistence on 58.5 to 76.4% of series, and the frozen models still score 0.952 to 0.963 on six months of data that did not exist when they were trained. A per-series exponential smoother matches us at 1 to 3 days, so our clear advantage is at 7 to 14 days.</a:t>
             </a:r>
           </a:p>
         </p:txBody>
@@ -1441,7 +1425,7 @@
             <a:spLocks noGrp="1"/>
           </p:cNvSpPr>
           <p:nvPr>
-            <p:ph type="sldNum" sz="quarter" idx="5"/>
+            <p:ph type="sldNum" idx="5" sz="quarter"/>
           </p:nvPr>
         </p:nvSpPr>
         <p:spPr/>
@@ -1455,7 +1439,7 @@
 </file>
 
 <file path=ppt/notesSlides/notesSlide9.xml><?xml version="1.0" encoding="utf-8"?>
-<p:notes xmlns:a="http://schemas.openxmlformats.org/drawingml/2006/main" xmlns:r="http://schemas.openxmlformats.org/officeDocument/2006/relationships" xmlns:p="http://schemas.openxmlformats.org/presentationml/2006/main">
+<p:notes xmlns:a="http://schemas.openxmlformats.org/drawingml/2006/main" xmlns:p="http://schemas.openxmlformats.org/presentationml/2006/main" xmlns:r="http://schemas.openxmlformats.org/officeDocument/2006/relationships">
   <p:cSld>
     <p:spTree>
       <p:nvGrpSpPr>
@@ -1490,7 +1474,7 @@
             <a:spLocks noGrp="1"/>
           </p:cNvSpPr>
           <p:nvPr>
-            <p:ph type="body" sz="quarter" idx="3"/>
+            <p:ph type="body" idx="3" sz="quarter"/>
           </p:nvPr>
         </p:nvSpPr>
         <p:spPr/>
@@ -1504,7 +1488,7 @@
           </a:p>
           <a:p>
             <a:r>
-              <a:t>Slide 9 covers the engineering challenges we overcame, honest project limitations, and next steps. On the left, we resolved JDK 21 reflection issues using `--add-opens`, date crashes using `coalesce`, shuffle OOM using composite deduplication, and recursive lineage using Parquet checkpoints. On the right, we honestly acknowledge our constraints: local[*] Spark execution, historical replay streaming, and future farmer advisory dispatch. The callout box highlights our deduplication fix, which saved the pipeline from JVM heap exhaustion. In conclusion, we have built and verified a complete distributed Big Data analytics pipeline.</a:t>
+              <a:t>Slide 9 covers challenges, honest limitations and what changed. On the left: JDK 21 reflection fixed with --add-opens, malformed dates handled with try_to_date, a hard persistence baseline that needed absolute-loss GBT, and an archive mirror that missed 70% of recent reports, which we fixed by back-filling official data. On the right: one-host Spark and HDFS, modest gains, and no public deployment. The callout box explains that we audited our v1 results and withdrew the anomaly-classifier and streaming figures that no code produced. In conclusion, our forecasts beat persistence by 3 to 8% at every horizon with calibrated intervals, and the gains held on six unseen months.</a:t>
             </a:r>
           </a:p>
           <a:p/>
@@ -1537,7 +1521,7 @@
           </a:p>
           <a:p>
             <a:r>
-              <a:t>Ma'am, deduplicating 132.9 million rows. A naive `distinct()` hashes all columns, causing severe shuffle skew and driver OOM. Partitioning over a 7-column composite business key enabled map-side partial reduction, allowing the job to finish in 4.2 minutes without memory spills.</a:t>
+              <a:t>Ma'am, data coverage. Our first models were trained and tested on the Kaggle archive, which after the AGMARKNET 2.0 migration looked like a performance drop. When we back-filled 7.7 million official records we found the archive held only 30% of official reports; re-scoring the same frozen models on complete data showed most of the apparent drop was missing reports, not model failure.</a:t>
             </a:r>
           </a:p>
         </p:txBody>
@@ -1549,7 +1533,7 @@
             <a:spLocks noGrp="1"/>
           </p:cNvSpPr>
           <p:nvPr>
-            <p:ph type="sldNum" sz="quarter" idx="5"/>
+            <p:ph type="sldNum" idx="5" sz="quarter"/>
           </p:nvPr>
         </p:nvSpPr>
         <p:spPr/>
@@ -1743,6 +1727,7 @@
           <a:p>
             <a:fld id="{5BCAD085-E8A6-8845-BD4E-CB4CCA059FC4}" type="datetimeFigureOut">
               <a:rPr lang="en-US" smtClean="0"/>
+              <a:t>1/27/13</a:t>
             </a:fld>
             <a:endParaRPr lang="en-US"/>
           </a:p>
@@ -1784,12 +1769,18 @@
           <a:p>
             <a:fld id="{C1FF6DA9-008F-8B48-92A6-B652298478BF}" type="slidenum">
               <a:rPr lang="en-US" smtClean="0"/>
+              <a:t>‹#›</a:t>
             </a:fld>
             <a:endParaRPr lang="en-US"/>
           </a:p>
         </p:txBody>
       </p:sp>
     </p:spTree>
+    <p:extLst>
+      <p:ext uri="{BB962C8B-B14F-4D97-AF65-F5344CB8AC3E}">
+        <p14:creationId xmlns:p14="http://schemas.microsoft.com/office/powerpoint/2010/main" val="3168075583"/>
+      </p:ext>
+    </p:extLst>
   </p:cSld>
   <p:clrMapOvr>
     <a:masterClrMapping/>
@@ -1857,7 +1848,6 @@
               <a:rPr lang="en-US" smtClean="0"/>
               <a:t>Click to edit Master text styles</a:t>
             </a:r>
-            <a:endParaRPr lang="en-US" smtClean="0"/>
           </a:p>
           <a:p>
             <a:pPr lvl="1"/>
@@ -1865,7 +1855,6 @@
               <a:rPr lang="en-US" smtClean="0"/>
               <a:t>Second level</a:t>
             </a:r>
-            <a:endParaRPr lang="en-US" smtClean="0"/>
           </a:p>
           <a:p>
             <a:pPr lvl="2"/>
@@ -1873,7 +1862,6 @@
               <a:rPr lang="en-US" smtClean="0"/>
               <a:t>Third level</a:t>
             </a:r>
-            <a:endParaRPr lang="en-US" smtClean="0"/>
           </a:p>
           <a:p>
             <a:pPr lvl="3"/>
@@ -1881,7 +1869,6 @@
               <a:rPr lang="en-US" smtClean="0"/>
               <a:t>Fourth level</a:t>
             </a:r>
-            <a:endParaRPr lang="en-US" smtClean="0"/>
           </a:p>
           <a:p>
             <a:pPr lvl="4"/>
@@ -1910,6 +1897,7 @@
           <a:p>
             <a:fld id="{5BCAD085-E8A6-8845-BD4E-CB4CCA059FC4}" type="datetimeFigureOut">
               <a:rPr lang="en-US" smtClean="0"/>
+              <a:t>1/27/13</a:t>
             </a:fld>
             <a:endParaRPr lang="en-US"/>
           </a:p>
@@ -1951,12 +1939,18 @@
           <a:p>
             <a:fld id="{C1FF6DA9-008F-8B48-92A6-B652298478BF}" type="slidenum">
               <a:rPr lang="en-US" smtClean="0"/>
+              <a:t>‹#›</a:t>
             </a:fld>
             <a:endParaRPr lang="en-US"/>
           </a:p>
         </p:txBody>
       </p:sp>
     </p:spTree>
+    <p:extLst>
+      <p:ext uri="{BB962C8B-B14F-4D97-AF65-F5344CB8AC3E}">
+        <p14:creationId xmlns:p14="http://schemas.microsoft.com/office/powerpoint/2010/main" val="2910927964"/>
+      </p:ext>
+    </p:extLst>
   </p:cSld>
   <p:clrMapOvr>
     <a:masterClrMapping/>
@@ -2034,7 +2028,6 @@
               <a:rPr lang="en-US" smtClean="0"/>
               <a:t>Click to edit Master text styles</a:t>
             </a:r>
-            <a:endParaRPr lang="en-US" smtClean="0"/>
           </a:p>
           <a:p>
             <a:pPr lvl="1"/>
@@ -2042,7 +2035,6 @@
               <a:rPr lang="en-US" smtClean="0"/>
               <a:t>Second level</a:t>
             </a:r>
-            <a:endParaRPr lang="en-US" smtClean="0"/>
           </a:p>
           <a:p>
             <a:pPr lvl="2"/>
@@ -2050,7 +2042,6 @@
               <a:rPr lang="en-US" smtClean="0"/>
               <a:t>Third level</a:t>
             </a:r>
-            <a:endParaRPr lang="en-US" smtClean="0"/>
           </a:p>
           <a:p>
             <a:pPr lvl="3"/>
@@ -2058,7 +2049,6 @@
               <a:rPr lang="en-US" smtClean="0"/>
               <a:t>Fourth level</a:t>
             </a:r>
-            <a:endParaRPr lang="en-US" smtClean="0"/>
           </a:p>
           <a:p>
             <a:pPr lvl="4"/>
@@ -2087,6 +2077,7 @@
           <a:p>
             <a:fld id="{5BCAD085-E8A6-8845-BD4E-CB4CCA059FC4}" type="datetimeFigureOut">
               <a:rPr lang="en-US" smtClean="0"/>
+              <a:t>1/27/13</a:t>
             </a:fld>
             <a:endParaRPr lang="en-US"/>
           </a:p>
@@ -2128,12 +2119,18 @@
           <a:p>
             <a:fld id="{C1FF6DA9-008F-8B48-92A6-B652298478BF}" type="slidenum">
               <a:rPr lang="en-US" smtClean="0"/>
+              <a:t>‹#›</a:t>
             </a:fld>
             <a:endParaRPr lang="en-US"/>
           </a:p>
         </p:txBody>
       </p:sp>
     </p:spTree>
+    <p:extLst>
+      <p:ext uri="{BB962C8B-B14F-4D97-AF65-F5344CB8AC3E}">
+        <p14:creationId xmlns:p14="http://schemas.microsoft.com/office/powerpoint/2010/main" val="3612223792"/>
+      </p:ext>
+    </p:extLst>
   </p:cSld>
   <p:clrMapOvr>
     <a:masterClrMapping/>
@@ -2201,7 +2198,6 @@
               <a:rPr lang="en-US" smtClean="0"/>
               <a:t>Click to edit Master text styles</a:t>
             </a:r>
-            <a:endParaRPr lang="en-US" smtClean="0"/>
           </a:p>
           <a:p>
             <a:pPr lvl="1"/>
@@ -2209,7 +2205,6 @@
               <a:rPr lang="en-US" smtClean="0"/>
               <a:t>Second level</a:t>
             </a:r>
-            <a:endParaRPr lang="en-US" smtClean="0"/>
           </a:p>
           <a:p>
             <a:pPr lvl="2"/>
@@ -2217,7 +2212,6 @@
               <a:rPr lang="en-US" smtClean="0"/>
               <a:t>Third level</a:t>
             </a:r>
-            <a:endParaRPr lang="en-US" smtClean="0"/>
           </a:p>
           <a:p>
             <a:pPr lvl="3"/>
@@ -2225,7 +2219,6 @@
               <a:rPr lang="en-US" smtClean="0"/>
               <a:t>Fourth level</a:t>
             </a:r>
-            <a:endParaRPr lang="en-US" smtClean="0"/>
           </a:p>
           <a:p>
             <a:pPr lvl="4"/>
@@ -2254,6 +2247,7 @@
           <a:p>
             <a:fld id="{5BCAD085-E8A6-8845-BD4E-CB4CCA059FC4}" type="datetimeFigureOut">
               <a:rPr lang="en-US" smtClean="0"/>
+              <a:t>1/27/13</a:t>
             </a:fld>
             <a:endParaRPr lang="en-US"/>
           </a:p>
@@ -2295,12 +2289,18 @@
           <a:p>
             <a:fld id="{C1FF6DA9-008F-8B48-92A6-B652298478BF}" type="slidenum">
               <a:rPr lang="en-US" smtClean="0"/>
+              <a:t>‹#›</a:t>
             </a:fld>
             <a:endParaRPr lang="en-US"/>
           </a:p>
         </p:txBody>
       </p:sp>
     </p:spTree>
+    <p:extLst>
+      <p:ext uri="{BB962C8B-B14F-4D97-AF65-F5344CB8AC3E}">
+        <p14:creationId xmlns:p14="http://schemas.microsoft.com/office/powerpoint/2010/main" val="2614314258"/>
+      </p:ext>
+    </p:extLst>
   </p:cSld>
   <p:clrMapOvr>
     <a:masterClrMapping/>
@@ -2473,7 +2473,6 @@
               <a:rPr lang="en-US" smtClean="0"/>
               <a:t>Click to edit Master text styles</a:t>
             </a:r>
-            <a:endParaRPr lang="en-US" smtClean="0"/>
           </a:p>
         </p:txBody>
       </p:sp>
@@ -2494,6 +2493,7 @@
           <a:p>
             <a:fld id="{5BCAD085-E8A6-8845-BD4E-CB4CCA059FC4}" type="datetimeFigureOut">
               <a:rPr lang="en-US" smtClean="0"/>
+              <a:t>1/27/13</a:t>
             </a:fld>
             <a:endParaRPr lang="en-US"/>
           </a:p>
@@ -2535,12 +2535,18 @@
           <a:p>
             <a:fld id="{C1FF6DA9-008F-8B48-92A6-B652298478BF}" type="slidenum">
               <a:rPr lang="en-US" smtClean="0"/>
+              <a:t>‹#›</a:t>
             </a:fld>
             <a:endParaRPr lang="en-US"/>
           </a:p>
         </p:txBody>
       </p:sp>
     </p:spTree>
+    <p:extLst>
+      <p:ext uri="{BB962C8B-B14F-4D97-AF65-F5344CB8AC3E}">
+        <p14:creationId xmlns:p14="http://schemas.microsoft.com/office/powerpoint/2010/main" val="960648375"/>
+      </p:ext>
+    </p:extLst>
   </p:cSld>
   <p:clrMapOvr>
     <a:masterClrMapping/>
@@ -2641,7 +2647,6 @@
               <a:rPr lang="en-US" smtClean="0"/>
               <a:t>Click to edit Master text styles</a:t>
             </a:r>
-            <a:endParaRPr lang="en-US" smtClean="0"/>
           </a:p>
           <a:p>
             <a:pPr lvl="1"/>
@@ -2649,7 +2654,6 @@
               <a:rPr lang="en-US" smtClean="0"/>
               <a:t>Second level</a:t>
             </a:r>
-            <a:endParaRPr lang="en-US" smtClean="0"/>
           </a:p>
           <a:p>
             <a:pPr lvl="2"/>
@@ -2657,7 +2661,6 @@
               <a:rPr lang="en-US" smtClean="0"/>
               <a:t>Third level</a:t>
             </a:r>
-            <a:endParaRPr lang="en-US" smtClean="0"/>
           </a:p>
           <a:p>
             <a:pPr lvl="3"/>
@@ -2665,7 +2668,6 @@
               <a:rPr lang="en-US" smtClean="0"/>
               <a:t>Fourth level</a:t>
             </a:r>
-            <a:endParaRPr lang="en-US" smtClean="0"/>
           </a:p>
           <a:p>
             <a:pPr lvl="4"/>
@@ -2730,7 +2732,6 @@
               <a:rPr lang="en-US" smtClean="0"/>
               <a:t>Click to edit Master text styles</a:t>
             </a:r>
-            <a:endParaRPr lang="en-US" smtClean="0"/>
           </a:p>
           <a:p>
             <a:pPr lvl="1"/>
@@ -2738,7 +2739,6 @@
               <a:rPr lang="en-US" smtClean="0"/>
               <a:t>Second level</a:t>
             </a:r>
-            <a:endParaRPr lang="en-US" smtClean="0"/>
           </a:p>
           <a:p>
             <a:pPr lvl="2"/>
@@ -2746,7 +2746,6 @@
               <a:rPr lang="en-US" smtClean="0"/>
               <a:t>Third level</a:t>
             </a:r>
-            <a:endParaRPr lang="en-US" smtClean="0"/>
           </a:p>
           <a:p>
             <a:pPr lvl="3"/>
@@ -2754,7 +2753,6 @@
               <a:rPr lang="en-US" smtClean="0"/>
               <a:t>Fourth level</a:t>
             </a:r>
-            <a:endParaRPr lang="en-US" smtClean="0"/>
           </a:p>
           <a:p>
             <a:pPr lvl="4"/>
@@ -2783,6 +2781,7 @@
           <a:p>
             <a:fld id="{5BCAD085-E8A6-8845-BD4E-CB4CCA059FC4}" type="datetimeFigureOut">
               <a:rPr lang="en-US" smtClean="0"/>
+              <a:t>1/27/13</a:t>
             </a:fld>
             <a:endParaRPr lang="en-US"/>
           </a:p>
@@ -2824,12 +2823,18 @@
           <a:p>
             <a:fld id="{C1FF6DA9-008F-8B48-92A6-B652298478BF}" type="slidenum">
               <a:rPr lang="en-US" smtClean="0"/>
+              <a:t>‹#›</a:t>
             </a:fld>
             <a:endParaRPr lang="en-US"/>
           </a:p>
         </p:txBody>
       </p:sp>
     </p:spTree>
+    <p:extLst>
+      <p:ext uri="{BB962C8B-B14F-4D97-AF65-F5344CB8AC3E}">
+        <p14:creationId xmlns:p14="http://schemas.microsoft.com/office/powerpoint/2010/main" val="2782244947"/>
+      </p:ext>
+    </p:extLst>
   </p:cSld>
   <p:clrMapOvr>
     <a:masterClrMapping/>
@@ -2943,7 +2948,6 @@
               <a:rPr lang="en-US" smtClean="0"/>
               <a:t>Click to edit Master text styles</a:t>
             </a:r>
-            <a:endParaRPr lang="en-US" smtClean="0"/>
           </a:p>
         </p:txBody>
       </p:sp>
@@ -3000,7 +3004,6 @@
               <a:rPr lang="en-US" smtClean="0"/>
               <a:t>Click to edit Master text styles</a:t>
             </a:r>
-            <a:endParaRPr lang="en-US" smtClean="0"/>
           </a:p>
           <a:p>
             <a:pPr lvl="1"/>
@@ -3008,7 +3011,6 @@
               <a:rPr lang="en-US" smtClean="0"/>
               <a:t>Second level</a:t>
             </a:r>
-            <a:endParaRPr lang="en-US" smtClean="0"/>
           </a:p>
           <a:p>
             <a:pPr lvl="2"/>
@@ -3016,7 +3018,6 @@
               <a:rPr lang="en-US" smtClean="0"/>
               <a:t>Third level</a:t>
             </a:r>
-            <a:endParaRPr lang="en-US" smtClean="0"/>
           </a:p>
           <a:p>
             <a:pPr lvl="3"/>
@@ -3024,7 +3025,6 @@
               <a:rPr lang="en-US" smtClean="0"/>
               <a:t>Fourth level</a:t>
             </a:r>
-            <a:endParaRPr lang="en-US" smtClean="0"/>
           </a:p>
           <a:p>
             <a:pPr lvl="4"/>
@@ -3098,7 +3098,6 @@
               <a:rPr lang="en-US" smtClean="0"/>
               <a:t>Click to edit Master text styles</a:t>
             </a:r>
-            <a:endParaRPr lang="en-US" smtClean="0"/>
           </a:p>
         </p:txBody>
       </p:sp>
@@ -3155,7 +3154,6 @@
               <a:rPr lang="en-US" smtClean="0"/>
               <a:t>Click to edit Master text styles</a:t>
             </a:r>
-            <a:endParaRPr lang="en-US" smtClean="0"/>
           </a:p>
           <a:p>
             <a:pPr lvl="1"/>
@@ -3163,7 +3161,6 @@
               <a:rPr lang="en-US" smtClean="0"/>
               <a:t>Second level</a:t>
             </a:r>
-            <a:endParaRPr lang="en-US" smtClean="0"/>
           </a:p>
           <a:p>
             <a:pPr lvl="2"/>
@@ -3171,7 +3168,6 @@
               <a:rPr lang="en-US" smtClean="0"/>
               <a:t>Third level</a:t>
             </a:r>
-            <a:endParaRPr lang="en-US" smtClean="0"/>
           </a:p>
           <a:p>
             <a:pPr lvl="3"/>
@@ -3179,7 +3175,6 @@
               <a:rPr lang="en-US" smtClean="0"/>
               <a:t>Fourth level</a:t>
             </a:r>
-            <a:endParaRPr lang="en-US" smtClean="0"/>
           </a:p>
           <a:p>
             <a:pPr lvl="4"/>
@@ -3208,6 +3203,7 @@
           <a:p>
             <a:fld id="{5BCAD085-E8A6-8845-BD4E-CB4CCA059FC4}" type="datetimeFigureOut">
               <a:rPr lang="en-US" smtClean="0"/>
+              <a:t>1/27/13</a:t>
             </a:fld>
             <a:endParaRPr lang="en-US"/>
           </a:p>
@@ -3249,12 +3245,18 @@
           <a:p>
             <a:fld id="{C1FF6DA9-008F-8B48-92A6-B652298478BF}" type="slidenum">
               <a:rPr lang="en-US" smtClean="0"/>
+              <a:t>‹#›</a:t>
             </a:fld>
             <a:endParaRPr lang="en-US"/>
           </a:p>
         </p:txBody>
       </p:sp>
     </p:spTree>
+    <p:extLst>
+      <p:ext uri="{BB962C8B-B14F-4D97-AF65-F5344CB8AC3E}">
+        <p14:creationId xmlns:p14="http://schemas.microsoft.com/office/powerpoint/2010/main" val="990158736"/>
+      </p:ext>
+    </p:extLst>
   </p:cSld>
   <p:clrMapOvr>
     <a:masterClrMapping/>
@@ -3319,6 +3321,7 @@
           <a:p>
             <a:fld id="{5BCAD085-E8A6-8845-BD4E-CB4CCA059FC4}" type="datetimeFigureOut">
               <a:rPr lang="en-US" smtClean="0"/>
+              <a:t>1/27/13</a:t>
             </a:fld>
             <a:endParaRPr lang="en-US"/>
           </a:p>
@@ -3360,12 +3363,18 @@
           <a:p>
             <a:fld id="{C1FF6DA9-008F-8B48-92A6-B652298478BF}" type="slidenum">
               <a:rPr lang="en-US" smtClean="0"/>
+              <a:t>‹#›</a:t>
             </a:fld>
             <a:endParaRPr lang="en-US"/>
           </a:p>
         </p:txBody>
       </p:sp>
     </p:spTree>
+    <p:extLst>
+      <p:ext uri="{BB962C8B-B14F-4D97-AF65-F5344CB8AC3E}">
+        <p14:creationId xmlns:p14="http://schemas.microsoft.com/office/powerpoint/2010/main" val="727027711"/>
+      </p:ext>
+    </p:extLst>
   </p:cSld>
   <p:clrMapOvr>
     <a:masterClrMapping/>
@@ -3407,6 +3416,7 @@
           <a:p>
             <a:fld id="{5BCAD085-E8A6-8845-BD4E-CB4CCA059FC4}" type="datetimeFigureOut">
               <a:rPr lang="en-US" smtClean="0"/>
+              <a:t>1/27/13</a:t>
             </a:fld>
             <a:endParaRPr lang="en-US"/>
           </a:p>
@@ -3448,12 +3458,18 @@
           <a:p>
             <a:fld id="{C1FF6DA9-008F-8B48-92A6-B652298478BF}" type="slidenum">
               <a:rPr lang="en-US" smtClean="0"/>
+              <a:t>‹#›</a:t>
             </a:fld>
             <a:endParaRPr lang="en-US"/>
           </a:p>
         </p:txBody>
       </p:sp>
     </p:spTree>
+    <p:extLst>
+      <p:ext uri="{BB962C8B-B14F-4D97-AF65-F5344CB8AC3E}">
+        <p14:creationId xmlns:p14="http://schemas.microsoft.com/office/powerpoint/2010/main" val="1212999818"/>
+      </p:ext>
+    </p:extLst>
   </p:cSld>
   <p:clrMapOvr>
     <a:masterClrMapping/>
@@ -3563,7 +3579,6 @@
               <a:rPr lang="en-US" smtClean="0"/>
               <a:t>Click to edit Master text styles</a:t>
             </a:r>
-            <a:endParaRPr lang="en-US" smtClean="0"/>
           </a:p>
           <a:p>
             <a:pPr lvl="1"/>
@@ -3571,7 +3586,6 @@
               <a:rPr lang="en-US" smtClean="0"/>
               <a:t>Second level</a:t>
             </a:r>
-            <a:endParaRPr lang="en-US" smtClean="0"/>
           </a:p>
           <a:p>
             <a:pPr lvl="2"/>
@@ -3579,7 +3593,6 @@
               <a:rPr lang="en-US" smtClean="0"/>
               <a:t>Third level</a:t>
             </a:r>
-            <a:endParaRPr lang="en-US" smtClean="0"/>
           </a:p>
           <a:p>
             <a:pPr lvl="3"/>
@@ -3587,7 +3600,6 @@
               <a:rPr lang="en-US" smtClean="0"/>
               <a:t>Fourth level</a:t>
             </a:r>
-            <a:endParaRPr lang="en-US" smtClean="0"/>
           </a:p>
           <a:p>
             <a:pPr lvl="4"/>
@@ -3661,7 +3673,6 @@
               <a:rPr lang="en-US" smtClean="0"/>
               <a:t>Click to edit Master text styles</a:t>
             </a:r>
-            <a:endParaRPr lang="en-US" smtClean="0"/>
           </a:p>
         </p:txBody>
       </p:sp>
@@ -3682,6 +3693,7 @@
           <a:p>
             <a:fld id="{5BCAD085-E8A6-8845-BD4E-CB4CCA059FC4}" type="datetimeFigureOut">
               <a:rPr lang="en-US" smtClean="0"/>
+              <a:t>1/27/13</a:t>
             </a:fld>
             <a:endParaRPr lang="en-US"/>
           </a:p>
@@ -3723,12 +3735,18 @@
           <a:p>
             <a:fld id="{C1FF6DA9-008F-8B48-92A6-B652298478BF}" type="slidenum">
               <a:rPr lang="en-US" smtClean="0"/>
+              <a:t>‹#›</a:t>
             </a:fld>
             <a:endParaRPr lang="en-US"/>
           </a:p>
         </p:txBody>
       </p:sp>
     </p:spTree>
+    <p:extLst>
+      <p:ext uri="{BB962C8B-B14F-4D97-AF65-F5344CB8AC3E}">
+        <p14:creationId xmlns:p14="http://schemas.microsoft.com/office/powerpoint/2010/main" val="1840726560"/>
+      </p:ext>
+    </p:extLst>
   </p:cSld>
   <p:clrMapOvr>
     <a:masterClrMapping/>
@@ -3908,7 +3926,6 @@
               <a:rPr lang="en-US" smtClean="0"/>
               <a:t>Click to edit Master text styles</a:t>
             </a:r>
-            <a:endParaRPr lang="en-US" smtClean="0"/>
           </a:p>
         </p:txBody>
       </p:sp>
@@ -3929,6 +3946,7 @@
           <a:p>
             <a:fld id="{5BCAD085-E8A6-8845-BD4E-CB4CCA059FC4}" type="datetimeFigureOut">
               <a:rPr lang="en-US" smtClean="0"/>
+              <a:t>1/27/13</a:t>
             </a:fld>
             <a:endParaRPr lang="en-US"/>
           </a:p>
@@ -3970,12 +3988,18 @@
           <a:p>
             <a:fld id="{C1FF6DA9-008F-8B48-92A6-B652298478BF}" type="slidenum">
               <a:rPr lang="en-US" smtClean="0"/>
+              <a:t>‹#›</a:t>
             </a:fld>
             <a:endParaRPr lang="en-US"/>
           </a:p>
         </p:txBody>
       </p:sp>
     </p:spTree>
+    <p:extLst>
+      <p:ext uri="{BB962C8B-B14F-4D97-AF65-F5344CB8AC3E}">
+        <p14:creationId xmlns:p14="http://schemas.microsoft.com/office/powerpoint/2010/main" val="3889236939"/>
+      </p:ext>
+    </p:extLst>
   </p:cSld>
   <p:clrMapOvr>
     <a:masterClrMapping/>
@@ -4068,7 +4092,6 @@
               <a:rPr lang="en-US" smtClean="0"/>
               <a:t>Click to edit Master text styles</a:t>
             </a:r>
-            <a:endParaRPr lang="en-US" smtClean="0"/>
           </a:p>
           <a:p>
             <a:pPr lvl="1"/>
@@ -4076,7 +4099,6 @@
               <a:rPr lang="en-US" smtClean="0"/>
               <a:t>Second level</a:t>
             </a:r>
-            <a:endParaRPr lang="en-US" smtClean="0"/>
           </a:p>
           <a:p>
             <a:pPr lvl="2"/>
@@ -4084,7 +4106,6 @@
               <a:rPr lang="en-US" smtClean="0"/>
               <a:t>Third level</a:t>
             </a:r>
-            <a:endParaRPr lang="en-US" smtClean="0"/>
           </a:p>
           <a:p>
             <a:pPr lvl="3"/>
@@ -4092,7 +4113,6 @@
               <a:rPr lang="en-US" smtClean="0"/>
               <a:t>Fourth level</a:t>
             </a:r>
-            <a:endParaRPr lang="en-US" smtClean="0"/>
           </a:p>
           <a:p>
             <a:pPr lvl="4"/>
@@ -4139,6 +4159,7 @@
           <a:p>
             <a:fld id="{5BCAD085-E8A6-8845-BD4E-CB4CCA059FC4}" type="datetimeFigureOut">
               <a:rPr lang="en-US" smtClean="0"/>
+              <a:t>1/27/13</a:t>
             </a:fld>
             <a:endParaRPr lang="en-US"/>
           </a:p>
@@ -4216,12 +4237,18 @@
           <a:p>
             <a:fld id="{C1FF6DA9-008F-8B48-92A6-B652298478BF}" type="slidenum">
               <a:rPr lang="en-US" smtClean="0"/>
+              <a:t>‹#›</a:t>
             </a:fld>
             <a:endParaRPr lang="en-US"/>
           </a:p>
         </p:txBody>
       </p:sp>
     </p:spTree>
+    <p:extLst>
+      <p:ext uri="{BB962C8B-B14F-4D97-AF65-F5344CB8AC3E}">
+        <p14:creationId xmlns:p14="http://schemas.microsoft.com/office/powerpoint/2010/main" val="2209977519"/>
+      </p:ext>
+    </p:extLst>
   </p:cSld>
   <p:clrMap bg1="lt1" tx1="dk1" bg2="lt2" tx2="dk2" accent1="accent1" accent2="accent2" accent3="accent3" accent4="accent4" accent5="accent5" accent6="accent6" hlink="hlink" folHlink="folHlink"/>
   <p:sldLayoutIdLst>
@@ -4259,7 +4286,7 @@
         <a:spcBef>
           <a:spcPct val="20000"/>
         </a:spcBef>
-        <a:buFont typeface="Arial" panose="020B0704020202020204"/>
+        <a:buFont typeface="Arial"/>
         <a:buChar char="•"/>
         <a:defRPr sz="3200" kern="1200">
           <a:solidFill>
@@ -4274,7 +4301,7 @@
         <a:spcBef>
           <a:spcPct val="20000"/>
         </a:spcBef>
-        <a:buFont typeface="Arial" panose="020B0704020202020204"/>
+        <a:buFont typeface="Arial"/>
         <a:buChar char="–"/>
         <a:defRPr sz="2800" kern="1200">
           <a:solidFill>
@@ -4289,7 +4316,7 @@
         <a:spcBef>
           <a:spcPct val="20000"/>
         </a:spcBef>
-        <a:buFont typeface="Arial" panose="020B0704020202020204"/>
+        <a:buFont typeface="Arial"/>
         <a:buChar char="•"/>
         <a:defRPr sz="2400" kern="1200">
           <a:solidFill>
@@ -4304,7 +4331,7 @@
         <a:spcBef>
           <a:spcPct val="20000"/>
         </a:spcBef>
-        <a:buFont typeface="Arial" panose="020B0704020202020204"/>
+        <a:buFont typeface="Arial"/>
         <a:buChar char="–"/>
         <a:defRPr sz="2000" kern="1200">
           <a:solidFill>
@@ -4319,7 +4346,7 @@
         <a:spcBef>
           <a:spcPct val="20000"/>
         </a:spcBef>
-        <a:buFont typeface="Arial" panose="020B0704020202020204"/>
+        <a:buFont typeface="Arial"/>
         <a:buChar char="»"/>
         <a:defRPr sz="2000" kern="1200">
           <a:solidFill>
@@ -4334,7 +4361,7 @@
         <a:spcBef>
           <a:spcPct val="20000"/>
         </a:spcBef>
-        <a:buFont typeface="Arial" panose="020B0704020202020204"/>
+        <a:buFont typeface="Arial"/>
         <a:buChar char="•"/>
         <a:defRPr sz="2000" kern="1200">
           <a:solidFill>
@@ -4349,7 +4376,7 @@
         <a:spcBef>
           <a:spcPct val="20000"/>
         </a:spcBef>
-        <a:buFont typeface="Arial" panose="020B0704020202020204"/>
+        <a:buFont typeface="Arial"/>
         <a:buChar char="•"/>
         <a:defRPr sz="2000" kern="1200">
           <a:solidFill>
@@ -4364,7 +4391,7 @@
         <a:spcBef>
           <a:spcPct val="20000"/>
         </a:spcBef>
-        <a:buFont typeface="Arial" panose="020B0704020202020204"/>
+        <a:buFont typeface="Arial"/>
         <a:buChar char="•"/>
         <a:defRPr sz="2000" kern="1200">
           <a:solidFill>
@@ -4379,7 +4406,7 @@
         <a:spcBef>
           <a:spcPct val="20000"/>
         </a:spcBef>
-        <a:buFont typeface="Arial" panose="020B0704020202020204"/>
+        <a:buFont typeface="Arial"/>
         <a:buChar char="•"/>
         <a:defRPr sz="2000" kern="1200">
           <a:solidFill>
@@ -4491,7 +4518,7 @@
 </file>
 
 <file path=ppt/slides/slide1.xml><?xml version="1.0" encoding="utf-8"?>
-<p:sld xmlns:a="http://schemas.openxmlformats.org/drawingml/2006/main" xmlns:r="http://schemas.openxmlformats.org/officeDocument/2006/relationships" xmlns:p="http://schemas.openxmlformats.org/presentationml/2006/main">
+<p:sld xmlns:a="http://schemas.openxmlformats.org/drawingml/2006/main" xmlns:p="http://schemas.openxmlformats.org/presentationml/2006/main" xmlns:r="http://schemas.openxmlformats.org/officeDocument/2006/relationships">
   <p:cSld>
     <p:spTree>
       <p:nvGrpSpPr>
@@ -4579,7 +4606,7 @@
           </a:fontRef>
         </p:style>
         <p:txBody>
-          <a:bodyPr wrap="square" tIns="73152" rtlCol="0" anchor="ctr"/>
+          <a:bodyPr rtlCol="0" anchor="ctr" wrap="square" tIns="73152"/>
           <a:lstStyle/>
           <a:p>
             <a:pPr algn="ctr">
@@ -4631,7 +4658,7 @@
           </a:fontRef>
         </p:style>
         <p:txBody>
-          <a:bodyPr wrap="square" tIns="73152" rtlCol="0" anchor="ctr"/>
+          <a:bodyPr rtlCol="0" anchor="ctr" wrap="square" tIns="73152"/>
           <a:lstStyle/>
           <a:p>
             <a:pPr algn="ctr">
@@ -4683,7 +4710,7 @@
           </a:fontRef>
         </p:style>
         <p:txBody>
-          <a:bodyPr wrap="square" tIns="73152" rtlCol="0" anchor="ctr"/>
+          <a:bodyPr rtlCol="0" anchor="ctr" wrap="square" tIns="73152"/>
           <a:lstStyle/>
           <a:p>
             <a:pPr algn="ctr">
@@ -4708,7 +4735,7 @@
         <p:spPr>
           <a:xfrm>
             <a:off x="548640" y="502920"/>
-            <a:ext cx="11094720" cy="1387475"/>
+            <a:ext cx="11094415" cy="1645920"/>
           </a:xfrm>
           <a:prstGeom prst="roundRect">
             <a:avLst/>
@@ -4753,7 +4780,7 @@
         <p:spPr>
           <a:xfrm>
             <a:off x="731520" y="640080"/>
-            <a:ext cx="10728655" cy="906780"/>
+            <a:ext cx="10728655" cy="1371600"/>
           </a:xfrm>
           <a:prstGeom prst="rect">
             <a:avLst/>
@@ -4774,10 +4801,8 @@
               </a:defRPr>
             </a:pPr>
             <a:r>
-              <a:rPr sz="2400"/>
               <a:t>Agricultural Commodity Price Forecasting and Market Analysis</a:t>
             </a:r>
-            <a:endParaRPr sz="2400"/>
           </a:p>
           <a:p>
             <a:pPr algn="ctr">
@@ -4791,10 +4816,8 @@
               </a:defRPr>
             </a:pPr>
             <a:r>
-              <a:rPr sz="2400"/>
               <a:t>Using Hadoop HDFS, Apache Spark, MLlib, and Apache Kafka</a:t>
             </a:r>
-            <a:endParaRPr sz="2400"/>
           </a:p>
         </p:txBody>
       </p:sp>
@@ -4806,8 +4829,8 @@
         </p:nvSpPr>
         <p:spPr>
           <a:xfrm>
-            <a:off x="4748378" y="2179955"/>
-            <a:ext cx="2694940" cy="352425"/>
+            <a:off x="731520" y="2331720"/>
+            <a:ext cx="10728655" cy="411480"/>
           </a:xfrm>
           <a:prstGeom prst="rect">
             <a:avLst/>
@@ -4828,13 +4851,8 @@
               </a:defRPr>
             </a:pPr>
             <a:r>
-              <a:t>Final Review — Team </a:t>
-            </a:r>
-            <a:r>
-              <a:rPr lang="en-US"/>
-              <a:t>14</a:t>
-            </a:r>
-            <a:endParaRPr lang="en-US"/>
+              <a:t>Final Review — Team AG-DATA</a:t>
+            </a:r>
           </a:p>
         </p:txBody>
       </p:sp>
@@ -4874,13 +4892,11 @@
                         </a:defRPr>
                       </a:pPr>
                       <a:r>
-                        <a:rPr sz="1600"/>
                         <a:t>Name</a:t>
                       </a:r>
-                      <a:endParaRPr sz="1600"/>
                     </a:p>
                   </a:txBody>
-                  <a:tcPr marL="137160" marR="137160" anchor="ctr">
+                  <a:tcPr anchor="ctr" marL="137160" marR="137160">
                     <a:solidFill>
                       <a:srgbClr val="E6EBF5"/>
                     </a:solidFill>
@@ -4899,13 +4915,11 @@
                         </a:defRPr>
                       </a:pPr>
                       <a:r>
-                        <a:rPr sz="1600"/>
                         <a:t>Register no.</a:t>
                       </a:r>
-                      <a:endParaRPr sz="1600"/>
                     </a:p>
                   </a:txBody>
-                  <a:tcPr marL="137160" marR="137160" anchor="ctr">
+                  <a:tcPr anchor="ctr" marL="137160" marR="137160">
                     <a:solidFill>
                       <a:srgbClr val="E6EBF5"/>
                     </a:solidFill>
@@ -4926,13 +4940,11 @@
                         </a:defRPr>
                       </a:pPr>
                       <a:r>
-                        <a:rPr sz="1600"/>
                         <a:t>C Rishitha</a:t>
                       </a:r>
-                      <a:endParaRPr sz="1600"/>
                     </a:p>
                   </a:txBody>
-                  <a:tcPr marL="137160" marR="137160" anchor="ctr">
+                  <a:tcPr anchor="ctr" marL="137160" marR="137160">
                     <a:solidFill>
                       <a:srgbClr val="FFFFFF"/>
                     </a:solidFill>
@@ -4951,13 +4963,11 @@
                         </a:defRPr>
                       </a:pPr>
                       <a:r>
-                        <a:rPr sz="1600"/>
                         <a:t>CB.AI.U4AID24109</a:t>
                       </a:r>
-                      <a:endParaRPr sz="1600"/>
                     </a:p>
                   </a:txBody>
-                  <a:tcPr marL="137160" marR="137160" anchor="ctr">
+                  <a:tcPr anchor="ctr" marL="137160" marR="137160">
                     <a:solidFill>
                       <a:srgbClr val="FFFFFF"/>
                     </a:solidFill>
@@ -4978,13 +4988,11 @@
                         </a:defRPr>
                       </a:pPr>
                       <a:r>
-                        <a:rPr sz="1600"/>
                         <a:t>Karthikeya Y</a:t>
                       </a:r>
-                      <a:endParaRPr sz="1600"/>
                     </a:p>
                   </a:txBody>
-                  <a:tcPr marL="137160" marR="137160" anchor="ctr">
+                  <a:tcPr anchor="ctr" marL="137160" marR="137160">
                     <a:solidFill>
                       <a:srgbClr val="F5F8FD"/>
                     </a:solidFill>
@@ -5003,13 +5011,11 @@
                         </a:defRPr>
                       </a:pPr>
                       <a:r>
-                        <a:rPr sz="1600"/>
                         <a:t>CB.AI.U4AID24163</a:t>
                       </a:r>
-                      <a:endParaRPr sz="1600"/>
                     </a:p>
                   </a:txBody>
-                  <a:tcPr marL="137160" marR="137160" anchor="ctr">
+                  <a:tcPr anchor="ctr" marL="137160" marR="137160">
                     <a:solidFill>
                       <a:srgbClr val="F5F8FD"/>
                     </a:solidFill>
@@ -5030,13 +5036,11 @@
                         </a:defRPr>
                       </a:pPr>
                       <a:r>
-                        <a:rPr sz="1600"/>
                         <a:t>Ashwin Tyagi</a:t>
                       </a:r>
-                      <a:endParaRPr sz="1600"/>
                     </a:p>
                   </a:txBody>
-                  <a:tcPr marL="137160" marR="137160" anchor="ctr">
+                  <a:tcPr anchor="ctr" marL="137160" marR="137160">
                     <a:solidFill>
                       <a:srgbClr val="FFFFFF"/>
                     </a:solidFill>
@@ -5055,13 +5059,11 @@
                         </a:defRPr>
                       </a:pPr>
                       <a:r>
-                        <a:rPr sz="1600"/>
                         <a:t>CB.AI.U4AID24167</a:t>
                       </a:r>
-                      <a:endParaRPr sz="1600"/>
                     </a:p>
                   </a:txBody>
-                  <a:tcPr marL="137160" marR="137160" anchor="ctr">
+                  <a:tcPr anchor="ctr" marL="137160" marR="137160">
                     <a:solidFill>
                       <a:srgbClr val="FFFFFF"/>
                     </a:solidFill>
@@ -5082,13 +5084,11 @@
                         </a:defRPr>
                       </a:pPr>
                       <a:r>
-                        <a:rPr sz="1600"/>
                         <a:t>Kaushal S</a:t>
                       </a:r>
-                      <a:endParaRPr sz="1600"/>
                     </a:p>
                   </a:txBody>
-                  <a:tcPr marL="137160" marR="137160" anchor="ctr">
+                  <a:tcPr anchor="ctr" marL="137160" marR="137160">
                     <a:solidFill>
                       <a:srgbClr val="F5F8FD"/>
                     </a:solidFill>
@@ -5107,13 +5107,11 @@
                         </a:defRPr>
                       </a:pPr>
                       <a:r>
-                        <a:rPr sz="1600"/>
                         <a:t>CB.AI.U4AID24168</a:t>
                       </a:r>
-                      <a:endParaRPr sz="1600"/>
                     </a:p>
                   </a:txBody>
-                  <a:tcPr marL="137160" marR="137160" anchor="ctr">
+                  <a:tcPr anchor="ctr" marL="137160" marR="137160">
                     <a:solidFill>
                       <a:srgbClr val="F5F8FD"/>
                     </a:solidFill>
@@ -5133,7 +5131,7 @@
         <p:spPr>
           <a:xfrm>
             <a:off x="731520" y="4983480"/>
-            <a:ext cx="10728655" cy="919480"/>
+            <a:ext cx="10728655" cy="1188720"/>
           </a:xfrm>
           <a:prstGeom prst="rect">
             <a:avLst/>
@@ -5154,10 +5152,8 @@
               </a:defRPr>
             </a:pPr>
             <a:r>
-              <a:rPr sz="1600"/>
               <a:t>23AID302 — Big Data Analytics</a:t>
             </a:r>
-            <a:endParaRPr sz="1600"/>
           </a:p>
           <a:p>
             <a:pPr algn="ctr">
@@ -5171,10 +5167,8 @@
               </a:defRPr>
             </a:pPr>
             <a:r>
-              <a:rPr sz="1600"/>
               <a:t>Department of Artificial Intelligence and Data Science  ·  Amrita Vishwa Vidyapeetham</a:t>
             </a:r>
-            <a:endParaRPr sz="1600"/>
           </a:p>
           <a:p>
             <a:pPr algn="ctr">
@@ -5188,10 +5182,8 @@
               </a:defRPr>
             </a:pPr>
             <a:r>
-              <a:rPr sz="1600"/>
               <a:t>Faculty Guide: Dr. Sreeja</a:t>
             </a:r>
-            <a:endParaRPr sz="1600"/>
           </a:p>
         </p:txBody>
       </p:sp>
@@ -5204,7 +5196,7 @@
 </file>
 
 <file path=ppt/slides/slide10.xml><?xml version="1.0" encoding="utf-8"?>
-<p:sld xmlns:a="http://schemas.openxmlformats.org/drawingml/2006/main" xmlns:r="http://schemas.openxmlformats.org/officeDocument/2006/relationships" xmlns:p="http://schemas.openxmlformats.org/presentationml/2006/main">
+<p:sld xmlns:a="http://schemas.openxmlformats.org/drawingml/2006/main" xmlns:p="http://schemas.openxmlformats.org/presentationml/2006/main" xmlns:r="http://schemas.openxmlformats.org/officeDocument/2006/relationships">
   <p:cSld>
     <p:spTree>
       <p:nvGrpSpPr>
@@ -5292,7 +5284,7 @@
           </a:fontRef>
         </p:style>
         <p:txBody>
-          <a:bodyPr wrap="square" tIns="73152" rtlCol="0" anchor="ctr"/>
+          <a:bodyPr rtlCol="0" anchor="ctr" wrap="square" tIns="73152"/>
           <a:lstStyle/>
           <a:p>
             <a:pPr algn="ctr">
@@ -5344,7 +5336,7 @@
           </a:fontRef>
         </p:style>
         <p:txBody>
-          <a:bodyPr wrap="square" tIns="73152" rtlCol="0" anchor="ctr"/>
+          <a:bodyPr rtlCol="0" anchor="ctr" wrap="square" tIns="73152"/>
           <a:lstStyle/>
           <a:p>
             <a:pPr algn="ctr">
@@ -5396,7 +5388,7 @@
           </a:fontRef>
         </p:style>
         <p:txBody>
-          <a:bodyPr wrap="square" tIns="73152" rtlCol="0" anchor="ctr"/>
+          <a:bodyPr rtlCol="0" anchor="ctr" wrap="square" tIns="73152"/>
           <a:lstStyle/>
           <a:p>
             <a:pPr algn="ctr">
@@ -5605,7 +5597,7 @@
               </a:defRPr>
             </a:pPr>
             <a:r>
-              <a:t>Project evidence: GitHub repository https://github.com/kaushalrog/AG-DATA, saved Parquet tables, and evaluation logs.</a:t>
+              <a:t>Project evidence: GitHub repository https://github.com/kaushalrog/AG-DATA; every figure with its source in docs/VERIFIED_METRICS.md.</a:t>
             </a:r>
           </a:p>
         </p:txBody>
@@ -5654,7 +5646,7 @@
 </file>
 
 <file path=ppt/slides/slide2.xml><?xml version="1.0" encoding="utf-8"?>
-<p:sld xmlns:a="http://schemas.openxmlformats.org/drawingml/2006/main" xmlns:r="http://schemas.openxmlformats.org/officeDocument/2006/relationships" xmlns:p="http://schemas.openxmlformats.org/presentationml/2006/main">
+<p:sld xmlns:a="http://schemas.openxmlformats.org/drawingml/2006/main" xmlns:p="http://schemas.openxmlformats.org/presentationml/2006/main" xmlns:r="http://schemas.openxmlformats.org/officeDocument/2006/relationships">
   <p:cSld>
     <p:spTree>
       <p:nvGrpSpPr>
@@ -5742,7 +5734,7 @@
           </a:fontRef>
         </p:style>
         <p:txBody>
-          <a:bodyPr wrap="square" tIns="73152" rtlCol="0" anchor="ctr"/>
+          <a:bodyPr rtlCol="0" anchor="ctr" wrap="square" tIns="73152"/>
           <a:lstStyle/>
           <a:p>
             <a:pPr algn="ctr">
@@ -5794,7 +5786,7 @@
           </a:fontRef>
         </p:style>
         <p:txBody>
-          <a:bodyPr wrap="square" tIns="73152" rtlCol="0" anchor="ctr"/>
+          <a:bodyPr rtlCol="0" anchor="ctr" wrap="square" tIns="73152"/>
           <a:lstStyle/>
           <a:p>
             <a:pPr algn="ctr">
@@ -5846,7 +5838,7 @@
           </a:fontRef>
         </p:style>
         <p:txBody>
-          <a:bodyPr wrap="square" tIns="73152" rtlCol="0" anchor="ctr"/>
+          <a:bodyPr rtlCol="0" anchor="ctr" wrap="square" tIns="73152"/>
           <a:lstStyle/>
           <a:p>
             <a:pPr algn="ctr">
@@ -6015,7 +6007,7 @@
               </a:defRPr>
             </a:pPr>
             <a:r>
-              <a:t>Mandi: unusual price fluctuations</a:t>
+              <a:t>Mandi: what price will be reported?</a:t>
             </a:r>
           </a:p>
         </p:txBody>
@@ -6029,7 +6021,7 @@
         <p:spPr>
           <a:xfrm>
             <a:off x="749808" y="1527048"/>
-            <a:ext cx="4946903" cy="1420495"/>
+            <a:ext cx="4946903" cy="2103120"/>
           </a:xfrm>
           <a:prstGeom prst="rect">
             <a:avLst/>
@@ -6050,10 +6042,8 @@
               </a:defRPr>
             </a:pPr>
             <a:r>
-              <a:rPr sz="1400"/>
-              <a:t>Find daily market transactions that exhibit abnormal price surges or crashes across 3,000+ Indian mandis.</a:t>
-            </a:r>
-            <a:endParaRPr sz="1400"/>
+              <a:t>Forecast the modal price a mandi will report 1, 3, 7 and 14 days ahead: 36 commodities, 11,845 mandi series.</a:t>
+            </a:r>
           </a:p>
           <a:p>
             <a:pPr>
@@ -6067,10 +6057,8 @@
               </a:defRPr>
             </a:pPr>
             <a:r>
-              <a:rPr sz="1400"/>
-              <a:t>Seasonal harvest gluts trigger sharp 40%+ price collapses, leading to severe distress selling by smallholder farmers.</a:t>
-            </a:r>
-            <a:endParaRPr sz="1400"/>
+              <a:t>Every forecast carries an 80% conformal interval whose test coverage is measured.</a:t>
+            </a:r>
           </a:p>
           <a:p>
             <a:pPr>
@@ -6084,10 +6072,8 @@
               </a:defRPr>
             </a:pPr>
             <a:r>
-              <a:rPr sz="1400"/>
-              <a:t>Use 7-day rolling window statistics, price spreads, and z-scores to give each transaction an anomaly risk label.</a:t>
-            </a:r>
-            <a:endParaRPr sz="1400"/>
+              <a:t>Baseline: persistence ("last price"), which is hard to beat: 17–34% of price changes are exactly zero.</a:t>
+            </a:r>
           </a:p>
         </p:txBody>
       </p:sp>
@@ -6209,7 +6195,7 @@
               </a:defRPr>
             </a:pPr>
             <a:r>
-              <a:t>Decision Support: farmer selling advisories</a:t>
+              <a:t>Decision Support: cautious outlook cards</a:t>
             </a:r>
           </a:p>
         </p:txBody>
@@ -6223,7 +6209,7 @@
         <p:spPr>
           <a:xfrm>
             <a:off x="6464807" y="1527048"/>
-            <a:ext cx="4946903" cy="2153920"/>
+            <a:ext cx="4946903" cy="2103120"/>
           </a:xfrm>
           <a:prstGeom prst="rect">
             <a:avLst/>
@@ -6244,10 +6230,8 @@
               </a:defRPr>
             </a:pPr>
             <a:r>
-              <a:rPr sz="1300"/>
-              <a:t>Translate price anomaly signals into practical domain recommendations:</a:t>
-            </a:r>
-            <a:endParaRPr sz="1300"/>
+              <a:t>Forecasts and intervals become cards a farmer can adjust with own costs:</a:t>
+            </a:r>
           </a:p>
           <a:p>
             <a:pPr>
@@ -6261,10 +6245,8 @@
               </a:defRPr>
             </a:pPr>
             <a:r>
-              <a:rPr sz="1300"/>
-              <a:t>• SELL: Recommend selling before an unpredicted post-spike glut collapses prices.</a:t>
-            </a:r>
-            <a:endParaRPr sz="1300"/>
+              <a:t>• SELL: Even the upper interval estimate is not above the last price.</a:t>
+            </a:r>
           </a:p>
           <a:p>
             <a:pPr>
@@ -6278,10 +6260,8 @@
               </a:defRPr>
             </a:pPr>
             <a:r>
-              <a:rPr sz="1300"/>
-              <a:t>• HOLD: Advise holding inventory during temporary panic dips when prices recover.</a:t>
-            </a:r>
-            <a:endParaRPr sz="1300"/>
+              <a:t>• HOLD: Even the lower estimate exceeds the last price plus storage costs.</a:t>
+            </a:r>
           </a:p>
           <a:p>
             <a:pPr>
@@ -6295,10 +6275,8 @@
               </a:defRPr>
             </a:pPr>
             <a:r>
-              <a:rPr sz="1300"/>
-              <a:t>• WATCH: High volatility alert; monitor market closely before dispatching produce.</a:t>
-            </a:r>
-            <a:endParaRPr sz="1300"/>
+              <a:t>• WATCH: No clear signal; the default card.</a:t>
+            </a:r>
           </a:p>
           <a:p>
             <a:pPr>
@@ -6312,10 +6290,8 @@
               </a:defRPr>
             </a:pPr>
             <a:r>
-              <a:rPr sz="1300"/>
-              <a:t>• BUY: Buyer/procurement advisory to acquire inventory before seasonal price surges.</a:t>
-            </a:r>
-            <a:endParaRPr sz="1300"/>
+              <a:t>• COMPARE: A nearby mandi recently reported a clearly higher price.</a:t>
+            </a:r>
           </a:p>
         </p:txBody>
       </p:sp>
@@ -6451,7 +6427,7 @@
         <p:spPr>
           <a:xfrm>
             <a:off x="777240" y="4416551"/>
-            <a:ext cx="10607040" cy="645795"/>
+            <a:ext cx="10607040" cy="1042415"/>
           </a:xfrm>
           <a:prstGeom prst="rect">
             <a:avLst/>
@@ -6472,10 +6448,8 @@
               </a:defRPr>
             </a:pPr>
             <a:r>
-              <a:rPr sz="1400"/>
-              <a:t>The agricultural files contain over 132.8 million market transactions (10.9 GB raw CSV). Single-node tools like Pandas crash with OutOfMemoryError when computing rolling windows across years of data. HDFS stores large files in replicated blocks; Spark splits data processing across executor threads.</a:t>
-            </a:r>
-            <a:endParaRPr sz="1400"/>
+              <a:t>The archive alone has 75.98 million mandi reports, and the forecast panel has 21.06 million feature rows built with per-series window functions. That does not fit single-node Pandas on a 16 GB laptop. HDFS stores the layers in replicated blocks; Spark splits the work across executor threads.</a:t>
+            </a:r>
           </a:p>
         </p:txBody>
       </p:sp>
@@ -6488,7 +6462,7 @@
         <p:spPr>
           <a:xfrm>
             <a:off x="548640" y="5715000"/>
-            <a:ext cx="7440930" cy="337185"/>
+            <a:ext cx="11064240" cy="365760"/>
           </a:xfrm>
           <a:prstGeom prst="rect">
             <a:avLst/>
@@ -6509,10 +6483,8 @@
               </a:defRPr>
             </a:pPr>
             <a:r>
-              <a:rPr sz="1600"/>
-              <a:t>Goal: prepare the data, compare models, and stream real-time price alerts.</a:t>
-            </a:r>
-            <a:endParaRPr sz="1600"/>
+              <a:t>Goal: prepare the data, compare forecasting models honestly, and stream daily reports.</a:t>
+            </a:r>
           </a:p>
         </p:txBody>
       </p:sp>
@@ -6525,7 +6497,7 @@
 </file>
 
 <file path=ppt/slides/slide3.xml><?xml version="1.0" encoding="utf-8"?>
-<p:sld xmlns:a="http://schemas.openxmlformats.org/drawingml/2006/main" xmlns:r="http://schemas.openxmlformats.org/officeDocument/2006/relationships" xmlns:p="http://schemas.openxmlformats.org/presentationml/2006/main">
+<p:sld xmlns:a="http://schemas.openxmlformats.org/drawingml/2006/main" xmlns:p="http://schemas.openxmlformats.org/presentationml/2006/main" xmlns:r="http://schemas.openxmlformats.org/officeDocument/2006/relationships">
   <p:cSld>
     <p:spTree>
       <p:nvGrpSpPr>
@@ -6613,7 +6585,7 @@
           </a:fontRef>
         </p:style>
         <p:txBody>
-          <a:bodyPr wrap="square" tIns="73152" rtlCol="0" anchor="ctr"/>
+          <a:bodyPr rtlCol="0" anchor="ctr" wrap="square" tIns="73152"/>
           <a:lstStyle/>
           <a:p>
             <a:pPr algn="ctr">
@@ -6665,7 +6637,7 @@
           </a:fontRef>
         </p:style>
         <p:txBody>
-          <a:bodyPr wrap="square" tIns="73152" rtlCol="0" anchor="ctr"/>
+          <a:bodyPr rtlCol="0" anchor="ctr" wrap="square" tIns="73152"/>
           <a:lstStyle/>
           <a:p>
             <a:pPr algn="ctr">
@@ -6717,7 +6689,7 @@
           </a:fontRef>
         </p:style>
         <p:txBody>
-          <a:bodyPr wrap="square" tIns="73152" rtlCol="0" anchor="ctr"/>
+          <a:bodyPr rtlCol="0" anchor="ctr" wrap="square" tIns="73152"/>
           <a:lstStyle/>
           <a:p>
             <a:pPr algn="ctr">
@@ -6777,7 +6749,7 @@
         <p:spPr>
           <a:xfrm>
             <a:off x="548640" y="1051560"/>
-            <a:ext cx="5349240" cy="4726305"/>
+            <a:ext cx="5349240" cy="4526280"/>
           </a:xfrm>
           <a:prstGeom prst="roundRect">
             <a:avLst/>
@@ -6886,7 +6858,7 @@
               </a:defRPr>
             </a:pPr>
             <a:r>
-              <a:t>Data already stored in HDFS</a:t>
+              <a:t>Data layers</a:t>
             </a:r>
           </a:p>
         </p:txBody>
@@ -6925,7 +6897,7 @@
         </p:nvGraphicFramePr>
         <p:xfrm>
           <a:off x="731520" y="1600200"/>
-          <a:ext cx="4983480" cy="2073275"/>
+          <a:ext cx="4983480" cy="2011680"/>
         </p:xfrm>
         <a:graphic>
           <a:graphicData uri="http://schemas.openxmlformats.org/drawingml/2006/table">
@@ -6956,7 +6928,7 @@
                       </a:r>
                     </a:p>
                   </a:txBody>
-                  <a:tcPr marL="73152" marR="73152" anchor="ctr">
+                  <a:tcPr anchor="ctr" marL="73152" marR="73152">
                     <a:solidFill>
                       <a:srgbClr val="E4EAF6"/>
                     </a:solidFill>
@@ -6979,7 +6951,7 @@
                       </a:r>
                     </a:p>
                   </a:txBody>
-                  <a:tcPr marL="73152" marR="73152" anchor="ctr">
+                  <a:tcPr anchor="ctr" marL="73152" marR="73152">
                     <a:solidFill>
                       <a:srgbClr val="E4EAF6"/>
                     </a:solidFill>
@@ -6998,11 +6970,11 @@
                         </a:defRPr>
                       </a:pPr>
                       <a:r>
-                        <a:t>Storage / Role</a:t>
+                        <a:t>Role</a:t>
                       </a:r>
                     </a:p>
                   </a:txBody>
-                  <a:tcPr marL="73152" marR="73152" anchor="ctr">
+                  <a:tcPr anchor="ctr" marL="73152" marR="73152">
                     <a:solidFill>
                       <a:srgbClr val="E4EAF6"/>
                     </a:solidFill>
@@ -7023,11 +6995,11 @@
                         </a:defRPr>
                       </a:pPr>
                       <a:r>
-                        <a:t>Source 1: Daily Market Prices</a:t>
+                        <a:t>Raw archive (Kaggle v134)</a:t>
                       </a:r>
                     </a:p>
                   </a:txBody>
-                  <a:tcPr marL="73152" marR="73152" anchor="ctr">
+                  <a:tcPr anchor="ctr" marL="73152" marR="73152">
                     <a:solidFill>
                       <a:srgbClr val="FFFFFF"/>
                     </a:solidFill>
@@ -7050,7 +7022,7 @@
                       </a:r>
                     </a:p>
                   </a:txBody>
-                  <a:tcPr marL="73152" marR="73152" anchor="ctr">
+                  <a:tcPr anchor="ctr" marL="73152" marR="73152">
                     <a:solidFill>
                       <a:srgbClr val="FFFFFF"/>
                     </a:solidFill>
@@ -7069,11 +7041,11 @@
                         </a:defRPr>
                       </a:pPr>
                       <a:r>
-                        <a:t>26 annual CSVs (6.5 GB)</a:t>
+                        <a:t>AGMARKNET 2001–2026</a:t>
                       </a:r>
                     </a:p>
                   </a:txBody>
-                  <a:tcPr marL="73152" marR="73152" anchor="ctr">
+                  <a:tcPr anchor="ctr" marL="73152" marR="73152">
                     <a:solidFill>
                       <a:srgbClr val="FFFFFF"/>
                     </a:solidFill>
@@ -7094,11 +7066,11 @@
                         </a:defRPr>
                       </a:pPr>
                       <a:r>
-                        <a:t>Source 2: India Mandi Dataset</a:t>
+                        <a:t>Archive silver</a:t>
                       </a:r>
                     </a:p>
                   </a:txBody>
-                  <a:tcPr marL="73152" marR="73152" anchor="ctr">
+                  <a:tcPr anchor="ctr" marL="73152" marR="73152">
                     <a:solidFill>
                       <a:srgbClr val="F5F8FD"/>
                     </a:solidFill>
@@ -7117,11 +7089,11 @@
                         </a:defRPr>
                       </a:pPr>
                       <a:r>
-                        <a:t>56,879,072</a:t>
+                        <a:t>75,644,801</a:t>
                       </a:r>
                     </a:p>
                   </a:txBody>
-                  <a:tcPr marL="73152" marR="73152" anchor="ctr">
+                  <a:tcPr anchor="ctr" marL="73152" marR="73152">
                     <a:solidFill>
                       <a:srgbClr val="F5F8FD"/>
                     </a:solidFill>
@@ -7140,18 +7112,18 @@
                         </a:defRPr>
                       </a:pPr>
                       <a:r>
-                        <a:t>325 commodity CSVs (4.4 GB)</a:t>
+                        <a:t>After quality + dedup</a:t>
                       </a:r>
                     </a:p>
                   </a:txBody>
-                  <a:tcPr marL="73152" marR="73152" anchor="ctr">
+                  <a:tcPr anchor="ctr" marL="73152" marR="73152">
                     <a:solidFill>
                       <a:srgbClr val="F5F8FD"/>
                     </a:solidFill>
                   </a:tcPr>
                 </a:tc>
               </a:tr>
-              <a:tr h="305435">
+              <a:tr h="335280">
                 <a:tc>
                   <a:txBody>
                     <a:bodyPr/>
@@ -7165,11 +7137,11 @@
                         </a:defRPr>
                       </a:pPr>
                       <a:r>
-                        <a:t>Deduplicated Output</a:t>
+                        <a:t>Official back-fill</a:t>
                       </a:r>
                     </a:p>
                   </a:txBody>
-                  <a:tcPr marL="73152" marR="73152" anchor="ctr">
+                  <a:tcPr anchor="ctr" marL="73152" marR="73152">
                     <a:solidFill>
                       <a:srgbClr val="FFFFFF"/>
                     </a:solidFill>
@@ -7188,11 +7160,11 @@
                         </a:defRPr>
                       </a:pPr>
                       <a:r>
-                        <a:t>132,327,828</a:t>
+                        <a:t>7,720,662</a:t>
                       </a:r>
                     </a:p>
                   </a:txBody>
-                  <a:tcPr marL="73152" marR="73152" anchor="ctr">
+                  <a:tcPr anchor="ctr" marL="73152" marR="73152">
                     <a:solidFill>
                       <a:srgbClr val="FFFFFF"/>
                     </a:solidFill>
@@ -7211,11 +7183,11 @@
                         </a:defRPr>
                       </a:pPr>
                       <a:r>
-                        <a:t>1.2 GB Parquet (9:1 ratio)</a:t>
+                        <a:t>data.gov.in, 2025-10 → 2026-10</a:t>
                       </a:r>
                     </a:p>
                   </a:txBody>
-                  <a:tcPr marL="73152" marR="73152" anchor="ctr">
+                  <a:tcPr anchor="ctr" marL="73152" marR="73152">
                     <a:solidFill>
                       <a:srgbClr val="FFFFFF"/>
                     </a:solidFill>
@@ -7236,11 +7208,11 @@
                         </a:defRPr>
                       </a:pPr>
                       <a:r>
-                        <a:t>Canonical Cleaned</a:t>
+                        <a:t>Silver v2</a:t>
                       </a:r>
                     </a:p>
                   </a:txBody>
-                  <a:tcPr marL="73152" marR="73152" anchor="ctr">
+                  <a:tcPr anchor="ctr" marL="73152" marR="73152">
                     <a:solidFill>
                       <a:srgbClr val="F5F8FD"/>
                     </a:solidFill>
@@ -7259,11 +7231,11 @@
                         </a:defRPr>
                       </a:pPr>
                       <a:r>
-                        <a:t>93,410,019</a:t>
+                        <a:t>82,114,083</a:t>
                       </a:r>
                     </a:p>
                   </a:txBody>
-                  <a:tcPr marL="73152" marR="73152" anchor="ctr">
+                  <a:tcPr anchor="ctr" marL="73152" marR="73152">
                     <a:solidFill>
                       <a:srgbClr val="F5F8FD"/>
                     </a:solidFill>
@@ -7282,11 +7254,11 @@
                         </a:defRPr>
                       </a:pPr>
                       <a:r>
-                        <a:t>Valid prices &amp; dates for ML</a:t>
+                        <a:t>Archive + official</a:t>
                       </a:r>
                     </a:p>
                   </a:txBody>
-                  <a:tcPr marL="73152" marR="73152" anchor="ctr">
+                  <a:tcPr anchor="ctr" marL="73152" marR="73152">
                     <a:solidFill>
                       <a:srgbClr val="F5F8FD"/>
                     </a:solidFill>
@@ -7307,11 +7279,11 @@
                         </a:defRPr>
                       </a:pPr>
                       <a:r>
-                        <a:t>Synthetic Stress Workload</a:t>
+                        <a:t>Forecast panel</a:t>
                       </a:r>
                     </a:p>
                   </a:txBody>
-                  <a:tcPr marL="73152" marR="73152" anchor="ctr">
+                  <a:tcPr anchor="ctr" marL="73152" marR="73152">
                     <a:solidFill>
                       <a:srgbClr val="FFFFFF"/>
                     </a:solidFill>
@@ -7330,11 +7302,11 @@
                         </a:defRPr>
                       </a:pPr>
                       <a:r>
-                        <a:t>350,012,867</a:t>
+                        <a:t>21.06 M</a:t>
                       </a:r>
                     </a:p>
                   </a:txBody>
-                  <a:tcPr marL="73152" marR="73152" anchor="ctr">
+                  <a:tcPr anchor="ctr" marL="73152" marR="73152">
                     <a:solidFill>
                       <a:srgbClr val="FFFFFF"/>
                     </a:solidFill>
@@ -7353,11 +7325,11 @@
                         </a:defRPr>
                       </a:pPr>
                       <a:r>
-                        <a:t>Isolated Phase 11 HDFS test</a:t>
+                        <a:t>36 commodities, 11,845 series</a:t>
                       </a:r>
                     </a:p>
                   </a:txBody>
-                  <a:tcPr marL="73152" marR="73152" anchor="ctr">
+                  <a:tcPr anchor="ctr" marL="73152" marR="73152">
                     <a:solidFill>
                       <a:srgbClr val="FFFFFF"/>
                     </a:solidFill>
@@ -7377,7 +7349,7 @@
         <p:spPr>
           <a:xfrm>
             <a:off x="731520" y="3749039"/>
-            <a:ext cx="4983480" cy="1435100"/>
+            <a:ext cx="4983480" cy="1737360"/>
           </a:xfrm>
           <a:prstGeom prst="rect">
             <a:avLst/>
@@ -7398,10 +7370,8 @@
               </a:defRPr>
             </a:pPr>
             <a:r>
-              <a:rPr sz="1400"/>
-              <a:t>Source 1: Agmarknet daily price records (2001–2026). Attributes: State, District, Market, Commodity, Arrival_Date, Min/Max/Modal Price.</a:t>
-            </a:r>
-            <a:endParaRPr sz="1400"/>
+              <a:t>Attributes: State, District, Market, Commodity, Variety, Grade, Arrival_Date, Min/Max/Modal Price.</a:t>
+            </a:r>
           </a:p>
           <a:p>
             <a:pPr>
@@ -7415,10 +7385,8 @@
               </a:defRPr>
             </a:pPr>
             <a:r>
-              <a:rPr sz="1400"/>
-              <a:t>Source 2: India Mandi dataset. Attributes: State, District, Market, Commodity, Variety, Group, Arrivals (Tonnes), Reported Date.</a:t>
-            </a:r>
-            <a:endParaRPr sz="1400"/>
+              <a:t>Coverage finding: the archive mirror holds only 30.0% of official reports for 2025-10 → 2026-04; where both exist, 99.33% of modal prices agree.</a:t>
+            </a:r>
           </a:p>
         </p:txBody>
       </p:sp>
@@ -7431,7 +7399,7 @@
         <p:spPr>
           <a:xfrm>
             <a:off x="6263640" y="1051560"/>
-            <a:ext cx="5172075" cy="4738370"/>
+            <a:ext cx="5349240" cy="4526280"/>
           </a:xfrm>
           <a:prstGeom prst="roundRect">
             <a:avLst/>
@@ -7476,7 +7444,7 @@
         <p:spPr>
           <a:xfrm>
             <a:off x="6263640" y="1051560"/>
-            <a:ext cx="5165725" cy="361315"/>
+            <a:ext cx="5349240" cy="384048"/>
           </a:xfrm>
           <a:prstGeom prst="roundRect">
             <a:avLst/>
@@ -7547,14 +7515,124 @@
       </p:sp>
       <p:sp>
         <p:nvSpPr>
+          <p:cNvPr id="16" name="TextBox 15"/>
+          <p:cNvSpPr txBox="1"/>
+          <p:nvPr/>
+        </p:nvSpPr>
+        <p:spPr>
+          <a:xfrm>
+            <a:off x="6464807" y="1527048"/>
+            <a:ext cx="4946903" cy="3977640"/>
+          </a:xfrm>
+          <a:prstGeom prst="rect">
+            <a:avLst/>
+          </a:prstGeom>
+          <a:noFill/>
+        </p:spPr>
+        <p:txBody>
+          <a:bodyPr wrap="square" lIns="0" tIns="0" rIns="0" bIns="0">
+            <a:spAutoFit/>
+          </a:bodyPr>
+          <a:lstStyle/>
+          <a:p>
+            <a:pPr>
+              <a:defRPr sz="1200" b="1">
+                <a:solidFill>
+                  <a:srgbClr val="1B2A6B"/>
+                </a:solidFill>
+              </a:defRPr>
+            </a:pPr>
+            <a:r>
+              <a:t>5 Vs         In our project                  </a:t>
+            </a:r>
+          </a:p>
+          <a:p>
+            <a:pPr>
+              <a:spcBef>
+                <a:spcPts val="600"/>
+              </a:spcBef>
+              <a:defRPr sz="1050">
+                <a:solidFill>
+                  <a:srgbClr val="141923"/>
+                </a:solidFill>
+              </a:defRPr>
+            </a:pPr>
+            <a:r>
+              <a:t>Volume       75.98M raw archive rows; 82.1M silver v2 rows; 692 MB silver Parquet in HDFS.</a:t>
+            </a:r>
+          </a:p>
+          <a:p>
+            <a:pPr>
+              <a:spcBef>
+                <a:spcPts val="600"/>
+              </a:spcBef>
+              <a:defRPr sz="1050">
+                <a:solidFill>
+                  <a:srgbClr val="141923"/>
+                </a:solidFill>
+              </a:defRPr>
+            </a:pPr>
+            <a:r>
+              <a:t>Velocity     Daily reports through Kafka topic agri.prices.v1 into Structured Streaming.</a:t>
+            </a:r>
+          </a:p>
+          <a:p>
+            <a:pPr>
+              <a:spcBef>
+                <a:spcPts val="600"/>
+              </a:spcBef>
+              <a:defRPr sz="1050">
+                <a:solidFill>
+                  <a:srgbClr val="141923"/>
+                </a:solidFill>
+              </a:defRPr>
+            </a:pPr>
+            <a:r>
+              <a:t>Variety      Archive CSV files and two official data.gov.in API resources.</a:t>
+            </a:r>
+          </a:p>
+          <a:p>
+            <a:pPr>
+              <a:spcBef>
+                <a:spcPts val="600"/>
+              </a:spcBef>
+              <a:defRPr sz="1050">
+                <a:solidFill>
+                  <a:srgbClr val="141923"/>
+                </a:solidFill>
+              </a:defRPr>
+            </a:pPr>
+            <a:r>
+              <a:t>Veracity     Quality rules, de-duplication, quarantine; 30% archive coverage found.</a:t>
+            </a:r>
+          </a:p>
+          <a:p>
+            <a:pPr>
+              <a:spcBef>
+                <a:spcPts val="600"/>
+              </a:spcBef>
+              <a:defRPr sz="1050">
+                <a:solidFill>
+                  <a:srgbClr val="141923"/>
+                </a:solidFill>
+              </a:defRPr>
+            </a:pPr>
+            <a:r>
+              <a:t>Value        Evaluated price forecasts with intervals and cautious decision cards.</a:t>
+            </a:r>
+          </a:p>
+        </p:txBody>
+      </p:sp>
+      <p:sp>
+        <p:nvSpPr>
           <p:cNvPr id="17" name="TextBox 16"/>
           <p:cNvSpPr txBox="1"/>
           <p:nvPr/>
         </p:nvSpPr>
         <p:spPr>
           <a:xfrm>
-            <a:off x="548640" y="5942330"/>
-            <a:ext cx="10475595" cy="306705"/>
+            <a:off x="548640" y="5715000"/>
+            <a:ext cx="11064240" cy="365760"/>
           </a:xfrm>
           <a:prstGeom prst="rect">
             <a:avLst/>
@@ -7575,279 +7653,11 @@
               </a:defRPr>
             </a:pPr>
             <a:r>
-              <a:rPr sz="1400"/>
-              <a:t>Real data (132.9M rows) trained and tested the models. An isolated 350M synthetic workload evaluated 18 GB storage scalability.</a:t>
-            </a:r>
-            <a:endParaRPr sz="1400"/>
-          </a:p>
-        </p:txBody>
-      </p:sp>
-      <p:graphicFrame>
-        <p:nvGraphicFramePr>
-          <p:cNvPr id="18" name="Table 17"/>
-          <p:cNvGraphicFramePr/>
-          <p:nvPr/>
-        </p:nvGraphicFramePr>
-        <p:xfrm>
-          <a:off x="6446520" y="1546860"/>
-          <a:ext cx="4726940" cy="3901440"/>
-        </p:xfrm>
-        <a:graphic>
-          <a:graphicData uri="http://schemas.openxmlformats.org/drawingml/2006/table">
-            <a:tbl>
-              <a:tblPr firstRow="1" bandRow="1">
-                <a:tableStyleId>{5C22544A-7EE6-4342-B048-85BDC9FD1C3A}</a:tableStyleId>
-              </a:tblPr>
-              <a:tblGrid>
-                <a:gridCol w="2363470"/>
-                <a:gridCol w="2363470"/>
-              </a:tblGrid>
-              <a:tr h="640080">
-                <a:tc>
-                  <a:txBody>
-                    <a:bodyPr/>
-                    <a:p>
-                      <a:pPr>
-                        <a:buNone/>
-                      </a:pPr>
-                      <a:r>
-                        <a:rPr sz="1400">
-                          <a:solidFill>
-                            <a:srgbClr val="000000"/>
-                          </a:solidFill>
-                          <a:sym typeface="+mn-ea"/>
-                        </a:rPr>
-                        <a:t>Volume</a:t>
-                      </a:r>
-                      <a:endParaRPr lang="en-US" sz="1400">
-                        <a:solidFill>
-                          <a:srgbClr val="000000"/>
-                        </a:solidFill>
-                        <a:sym typeface="+mn-ea"/>
-                      </a:endParaRPr>
-                    </a:p>
-                  </a:txBody>
-                  <a:tcPr>
-                    <a:solidFill>
-                      <a:srgbClr val="E9EDF4"/>
-                    </a:solidFill>
-                  </a:tcPr>
-                </a:tc>
-                <a:tc>
-                  <a:txBody>
-                    <a:bodyPr/>
-                    <a:p>
-                      <a:pPr>
-                        <a:buNone/>
-                      </a:pPr>
-                      <a:r>
-                        <a:rPr sz="1200" b="0">
-                          <a:solidFill>
-                            <a:srgbClr val="000000"/>
-                          </a:solidFill>
-                          <a:sym typeface="+mn-ea"/>
-                        </a:rPr>
-                        <a:t>10.9 GB raw CSV in HDFS (132.9M real rows). Scaled to 18.15 GiB for stress testing.</a:t>
-                      </a:r>
-                      <a:endParaRPr lang="en-US" sz="1200" b="0">
-                        <a:solidFill>
-                          <a:srgbClr val="000000"/>
-                        </a:solidFill>
-                        <a:sym typeface="+mn-ea"/>
-                      </a:endParaRPr>
-                    </a:p>
-                  </a:txBody>
-                  <a:tcPr>
-                    <a:solidFill>
-                      <a:srgbClr val="E9EDF4"/>
-                    </a:solidFill>
-                  </a:tcPr>
-                </a:tc>
-              </a:tr>
-              <a:tr h="640080">
-                <a:tc>
-                  <a:txBody>
-                    <a:bodyPr/>
-                    <a:p>
-                      <a:pPr>
-                        <a:buNone/>
-                      </a:pPr>
-                      <a:r>
-                        <a:rPr sz="1400">
-                          <a:sym typeface="+mn-ea"/>
-                        </a:rPr>
-                        <a:t>Velocity</a:t>
-                      </a:r>
-                      <a:endParaRPr lang="en-US" sz="1400"/>
-                    </a:p>
-                    <a:p>
-                      <a:pPr>
-                        <a:buNone/>
-                      </a:pPr>
-                      <a:endParaRPr lang="en-US" sz="1400"/>
-                    </a:p>
-                  </a:txBody>
-                  <a:tcPr/>
-                </a:tc>
-                <a:tc>
-                  <a:txBody>
-                    <a:bodyPr/>
-                    <a:p>
-                      <a:pPr>
-                        <a:buNone/>
-                      </a:pPr>
-                      <a:r>
-                        <a:rPr sz="1200">
-                          <a:sym typeface="+mn-ea"/>
-                        </a:rPr>
-                        <a:t>Replay daily mandi arrivals in streaming micro-batches via Apache Kafka.</a:t>
-                      </a:r>
-                      <a:endParaRPr lang="en-US" sz="1200">
-                        <a:sym typeface="+mn-ea"/>
-                      </a:endParaRPr>
-                    </a:p>
-                  </a:txBody>
-                  <a:tcPr/>
-                </a:tc>
-              </a:tr>
-              <a:tr h="944880">
-                <a:tc>
-                  <a:txBody>
-                    <a:bodyPr/>
-                    <a:p>
-                      <a:pPr>
-                        <a:buNone/>
-                      </a:pPr>
-                      <a:r>
-                        <a:rPr sz="1400">
-                          <a:sym typeface="+mn-ea"/>
-                        </a:rPr>
-                        <a:t>Variety</a:t>
-                      </a:r>
-                      <a:endParaRPr lang="en-US" sz="1400"/>
-                    </a:p>
-                    <a:p>
-                      <a:pPr>
-                        <a:buNone/>
-                      </a:pPr>
-                      <a:endParaRPr lang="en-US" sz="1400"/>
-                    </a:p>
-                  </a:txBody>
-                  <a:tcPr/>
-                </a:tc>
-                <a:tc>
-                  <a:txBody>
-                    <a:bodyPr/>
-                    <a:p>
-                      <a:pPr>
-                        <a:buNone/>
-                      </a:pPr>
-                      <a:r>
-                        <a:rPr sz="1400">
-                          <a:sym typeface="+mn-ea"/>
-                        </a:rPr>
-                        <a:t>2 disparate sources: 26 annual CSVs vs 325 commodity CSVs; mixed date formats.</a:t>
-                      </a:r>
-                      <a:endParaRPr lang="en-US" sz="1400">
-                        <a:sym typeface="+mn-ea"/>
-                      </a:endParaRPr>
-                    </a:p>
-                  </a:txBody>
-                  <a:tcPr/>
-                </a:tc>
-              </a:tr>
-              <a:tr h="731520">
-                <a:tc>
-                  <a:txBody>
-                    <a:bodyPr/>
-                    <a:p>
-                      <a:pPr>
-                        <a:buNone/>
-                      </a:pPr>
-                      <a:r>
-                        <a:rPr sz="1400">
-                          <a:sym typeface="+mn-ea"/>
-                        </a:rPr>
-                        <a:t>Veracity </a:t>
-                      </a:r>
-                      <a:endParaRPr lang="en-US" sz="1400"/>
-                    </a:p>
-                    <a:p>
-                      <a:pPr>
-                        <a:buNone/>
-                      </a:pPr>
-                      <a:endParaRPr lang="en-US" sz="1400"/>
-                    </a:p>
-                  </a:txBody>
-                  <a:tcPr/>
-                </a:tc>
-                <a:tc>
-                  <a:txBody>
-                    <a:bodyPr/>
-                    <a:p>
-                      <a:pPr>
-                        <a:buNone/>
-                      </a:pPr>
-                      <a:r>
-                        <a:rPr sz="1400">
-                          <a:sym typeface="+mn-ea"/>
-                        </a:rPr>
-                        <a:t>Check missing, negative spreads, and 535k duplicate transactions.</a:t>
-                      </a:r>
-                      <a:endParaRPr lang="en-US" sz="1400">
-                        <a:sym typeface="+mn-ea"/>
-                      </a:endParaRPr>
-                    </a:p>
-                  </a:txBody>
-                  <a:tcPr/>
-                </a:tc>
-              </a:tr>
-              <a:tr h="944880">
-                <a:tc>
-                  <a:txBody>
-                    <a:bodyPr/>
-                    <a:p>
-                      <a:pPr>
-                        <a:buNone/>
-                      </a:pPr>
-                      <a:r>
-                        <a:rPr sz="1400">
-                          <a:sym typeface="+mn-ea"/>
-                        </a:rPr>
-                        <a:t>Value</a:t>
-                      </a:r>
-                      <a:endParaRPr lang="en-US" sz="1400">
-                        <a:sym typeface="+mn-ea"/>
-                      </a:endParaRPr>
-                    </a:p>
-                  </a:txBody>
-                  <a:tcPr/>
-                </a:tc>
-                <a:tc>
-                  <a:txBody>
-                    <a:bodyPr/>
-                    <a:p>
-                      <a:pPr>
-                        <a:buNone/>
-                      </a:pPr>
-                      <a:r>
-                        <a:rPr sz="1400">
-                          <a:sym typeface="+mn-ea"/>
-                        </a:rPr>
-                        <a:t>Help farmers and officials detect sudden price shocks and prevent distress selling.</a:t>
-                      </a:r>
-                      <a:endParaRPr lang="en-US" sz="1400">
-                        <a:sym typeface="+mn-ea"/>
-                      </a:endParaRPr>
-                    </a:p>
-                  </a:txBody>
-                  <a:tcPr/>
-                </a:tc>
-              </a:tr>
-            </a:tbl>
-          </a:graphicData>
-        </a:graphic>
-      </p:graphicFrame>
+              <a:t>All models are trained and tested on real data only. A v1 synthetic workload exists for scalability tests and is never used for any model.</a:t>
+            </a:r>
+          </a:p>
+        </p:txBody>
+      </p:sp>
     </p:spTree>
   </p:cSld>
   <p:clrMapOvr>
@@ -7857,7 +7667,7 @@
 </file>
 
 <file path=ppt/slides/slide4.xml><?xml version="1.0" encoding="utf-8"?>
-<p:sld xmlns:a="http://schemas.openxmlformats.org/drawingml/2006/main" xmlns:r="http://schemas.openxmlformats.org/officeDocument/2006/relationships" xmlns:p="http://schemas.openxmlformats.org/presentationml/2006/main">
+<p:sld xmlns:a="http://schemas.openxmlformats.org/drawingml/2006/main" xmlns:p="http://schemas.openxmlformats.org/presentationml/2006/main" xmlns:r="http://schemas.openxmlformats.org/officeDocument/2006/relationships">
   <p:cSld>
     <p:spTree>
       <p:nvGrpSpPr>
@@ -7945,7 +7755,7 @@
           </a:fontRef>
         </p:style>
         <p:txBody>
-          <a:bodyPr wrap="square" tIns="73152" rtlCol="0" anchor="ctr"/>
+          <a:bodyPr rtlCol="0" anchor="ctr" wrap="square" tIns="73152"/>
           <a:lstStyle/>
           <a:p>
             <a:pPr algn="ctr">
@@ -7997,7 +7807,7 @@
           </a:fontRef>
         </p:style>
         <p:txBody>
-          <a:bodyPr wrap="square" tIns="73152" rtlCol="0" anchor="ctr"/>
+          <a:bodyPr rtlCol="0" anchor="ctr" wrap="square" tIns="73152"/>
           <a:lstStyle/>
           <a:p>
             <a:pPr algn="ctr">
@@ -8049,7 +7859,7 @@
           </a:fontRef>
         </p:style>
         <p:txBody>
-          <a:bodyPr wrap="square" tIns="73152" rtlCol="0" anchor="ctr"/>
+          <a:bodyPr rtlCol="0" anchor="ctr" wrap="square" tIns="73152"/>
           <a:lstStyle/>
           <a:p>
             <a:pPr algn="ctr">
@@ -8138,7 +7948,7 @@
           </a:fontRef>
         </p:style>
         <p:txBody>
-          <a:bodyPr wrap="square" tIns="109728" rtlCol="0" anchor="ctr"/>
+          <a:bodyPr rtlCol="0" anchor="ctr" wrap="square" tIns="109728"/>
           <a:lstStyle/>
           <a:p>
             <a:pPr algn="ctr">
@@ -8161,11 +7971,11 @@
               </a:defRPr>
             </a:pPr>
             <a:r>
-              <a:t>351 CSVs</a:t>
+              <a:t>Archive CSV</a:t>
             </a:r>
             <a:br/>
             <a:r>
-              <a:t>(10.9 GB)</a:t>
+              <a:t>+ official API</a:t>
             </a:r>
           </a:p>
         </p:txBody>
@@ -8251,7 +8061,7 @@
           </a:fontRef>
         </p:style>
         <p:txBody>
-          <a:bodyPr wrap="square" tIns="109728" rtlCol="0" anchor="ctr"/>
+          <a:bodyPr rtlCol="0" anchor="ctr" wrap="square" tIns="109728"/>
           <a:lstStyle/>
           <a:p>
             <a:pPr algn="ctr">
@@ -8364,7 +8174,7 @@
           </a:fontRef>
         </p:style>
         <p:txBody>
-          <a:bodyPr wrap="square" tIns="109728" rtlCol="0" anchor="ctr"/>
+          <a:bodyPr rtlCol="0" anchor="ctr" wrap="square" tIns="109728"/>
           <a:lstStyle/>
           <a:p>
             <a:pPr algn="ctr">
@@ -8477,7 +8287,7 @@
           </a:fontRef>
         </p:style>
         <p:txBody>
-          <a:bodyPr wrap="square" tIns="109728" rtlCol="0" anchor="ctr"/>
+          <a:bodyPr rtlCol="0" anchor="ctr" wrap="square" tIns="109728"/>
           <a:lstStyle/>
           <a:p>
             <a:pPr algn="ctr">
@@ -8500,11 +8310,11 @@
               </a:defRPr>
             </a:pPr>
             <a:r>
-              <a:t>Build features</a:t>
+              <a:t>Features</a:t>
             </a:r>
             <a:br/>
             <a:r>
-              <a:t>and models</a:t>
+              <a:t>&amp; forecasts</a:t>
             </a:r>
           </a:p>
         </p:txBody>
@@ -8590,7 +8400,7 @@
           </a:fontRef>
         </p:style>
         <p:txBody>
-          <a:bodyPr wrap="square" tIns="109728" rtlCol="0" anchor="ctr"/>
+          <a:bodyPr rtlCol="0" anchor="ctr" wrap="square" tIns="109728"/>
           <a:lstStyle/>
           <a:p>
             <a:pPr algn="ctr">
@@ -8613,11 +8423,11 @@
               </a:defRPr>
             </a:pPr>
             <a:r>
-              <a:t>Alerts, charts</a:t>
+              <a:t>Gold, API</a:t>
             </a:r>
             <a:br/>
             <a:r>
-              <a:t>&amp; dashboard</a:t>
+              <a:t>&amp; PWA</a:t>
             </a:r>
           </a:p>
         </p:txBody>
@@ -8754,7 +8564,7 @@
         <p:spPr>
           <a:xfrm>
             <a:off x="749808" y="2761488"/>
-            <a:ext cx="4946903" cy="1015365"/>
+            <a:ext cx="4946903" cy="1828800"/>
           </a:xfrm>
           <a:prstGeom prst="rect">
             <a:avLst/>
@@ -8775,10 +8585,8 @@
               </a:defRPr>
             </a:pPr>
             <a:r>
-              <a:rPr sz="1400"/>
-              <a:t>• 1 NameNode + 3 DataNodes (Docker cluster).</a:t>
-            </a:r>
-            <a:endParaRPr sz="1400"/>
+              <a:t>• 1 NameNode + 3 DataNodes (Docker, one host).</a:t>
+            </a:r>
           </a:p>
           <a:p>
             <a:pPr>
@@ -8792,10 +8600,8 @@
               </a:defRPr>
             </a:pPr>
             <a:r>
-              <a:rPr sz="1400"/>
-              <a:t>• Block size: 128 MiB (standard for large Parquet blocks).</a:t>
-            </a:r>
-            <a:endParaRPr sz="1400"/>
+              <a:t>• Block size: 128 MiB; replication: 3 copies of each block.</a:t>
+            </a:r>
           </a:p>
           <a:p>
             <a:pPr>
@@ -8809,10 +8615,8 @@
               </a:defRPr>
             </a:pPr>
             <a:r>
-              <a:rPr sz="1400"/>
-              <a:t>• Replication: 3 copies of each block for fault tolerance.</a:t>
-            </a:r>
-            <a:endParaRPr sz="1400"/>
+              <a:t>• Silver layer: 692 MB, HEALTHY; readable with 1 DataNode down.</a:t>
+            </a:r>
           </a:p>
           <a:p>
             <a:pPr>
@@ -8826,10 +8630,8 @@
               </a:defRPr>
             </a:pPr>
             <a:r>
-              <a:rPr sz="1400"/>
               <a:t>• Clean output: Snappy Parquet, partitioned by year.</a:t>
             </a:r>
-            <a:endParaRPr sz="1400"/>
           </a:p>
         </p:txBody>
       </p:sp>
@@ -8965,7 +8767,7 @@
         <p:spPr>
           <a:xfrm>
             <a:off x="6464807" y="2761488"/>
-            <a:ext cx="4946903" cy="1015365"/>
+            <a:ext cx="4946903" cy="1828800"/>
           </a:xfrm>
           <a:prstGeom prst="rect">
             <a:avLst/>
@@ -8986,10 +8788,8 @@
               </a:defRPr>
             </a:pPr>
             <a:r>
-              <a:rPr sz="1400"/>
-              <a:t>• Engine: Apache Spark 4.2.0 in local[*] mode.</a:t>
-            </a:r>
-            <a:endParaRPr sz="1400"/>
+              <a:t>• Engine: Apache Spark 4.2 in local[*] mode (10 cores).</a:t>
+            </a:r>
           </a:p>
           <a:p>
             <a:pPr>
@@ -9003,10 +8803,8 @@
               </a:defRPr>
             </a:pPr>
             <a:r>
-              <a:rPr sz="1400"/>
               <a:t>• Multi-core local CPU threads (NOT YARN worker executors).</a:t>
             </a:r>
-            <a:endParaRPr sz="1400"/>
           </a:p>
           <a:p>
             <a:pPr>
@@ -9020,10 +8818,8 @@
               </a:defRPr>
             </a:pPr>
             <a:r>
-              <a:rPr sz="1400"/>
-              <a:t>• Memory: 4 GB driver / executor heap memory.</a:t>
-            </a:r>
-            <a:endParaRPr sz="1400"/>
+              <a:t>• Also benchmarked: Docker Spark cluster, 2 workers × 3 cores.</a:t>
+            </a:r>
           </a:p>
           <a:p>
             <a:pPr>
@@ -9037,10 +8833,8 @@
               </a:defRPr>
             </a:pPr>
             <a:r>
-              <a:rPr sz="1400"/>
-              <a:t>• Shuffle partitions: 200 partitions for balanced core utilization.</a:t>
-            </a:r>
-            <a:endParaRPr sz="1400"/>
+              <a:t>• Shuffle partitions: 64 in the forecast jobs, coalesced by AQE.</a:t>
+            </a:r>
           </a:p>
         </p:txBody>
       </p:sp>
@@ -9176,7 +8970,7 @@
         <p:spPr>
           <a:xfrm>
             <a:off x="777240" y="5239512"/>
-            <a:ext cx="10607040" cy="430530"/>
+            <a:ext cx="10607040" cy="813815"/>
           </a:xfrm>
           <a:prstGeom prst="rect">
             <a:avLst/>
@@ -9197,10 +8991,8 @@
               </a:defRPr>
             </a:pPr>
             <a:r>
-              <a:rPr sz="1400"/>
-              <a:t>No. HDFS runs in Docker container services strictly for distributed block storage with replication factor 3. Spark runs in local[*] mode on host CPU cores. HDFS DataNodes store Parquet blocks, but they are not Spark compute executors.</a:t>
-            </a:r>
-            <a:endParaRPr sz="1400"/>
+              <a:t>No. HDFS runs in Docker containers strictly for block storage with replication factor 3; Spark runs in local[*] mode on host CPU cores. The three DataNodes share one physical disk, so replication shows HDFS behaviour, not hardware durability.</a:t>
+            </a:r>
           </a:p>
         </p:txBody>
       </p:sp>
@@ -9213,7 +9005,7 @@
 </file>
 
 <file path=ppt/slides/slide5.xml><?xml version="1.0" encoding="utf-8"?>
-<p:sld xmlns:a="http://schemas.openxmlformats.org/drawingml/2006/main" xmlns:r="http://schemas.openxmlformats.org/officeDocument/2006/relationships" xmlns:p="http://schemas.openxmlformats.org/presentationml/2006/main">
+<p:sld xmlns:a="http://schemas.openxmlformats.org/drawingml/2006/main" xmlns:p="http://schemas.openxmlformats.org/presentationml/2006/main" xmlns:r="http://schemas.openxmlformats.org/officeDocument/2006/relationships">
   <p:cSld>
     <p:spTree>
       <p:nvGrpSpPr>
@@ -9301,7 +9093,7 @@
           </a:fontRef>
         </p:style>
         <p:txBody>
-          <a:bodyPr wrap="square" tIns="73152" rtlCol="0" anchor="ctr"/>
+          <a:bodyPr rtlCol="0" anchor="ctr" wrap="square" tIns="73152"/>
           <a:lstStyle/>
           <a:p>
             <a:pPr algn="ctr">
@@ -9353,7 +9145,7 @@
           </a:fontRef>
         </p:style>
         <p:txBody>
-          <a:bodyPr wrap="square" tIns="73152" rtlCol="0" anchor="ctr"/>
+          <a:bodyPr rtlCol="0" anchor="ctr" wrap="square" tIns="73152"/>
           <a:lstStyle/>
           <a:p>
             <a:pPr algn="ctr">
@@ -9405,7 +9197,7 @@
           </a:fontRef>
         </p:style>
         <p:txBody>
-          <a:bodyPr wrap="square" tIns="73152" rtlCol="0" anchor="ctr"/>
+          <a:bodyPr rtlCol="0" anchor="ctr" wrap="square" tIns="73152"/>
           <a:lstStyle/>
           <a:p>
             <a:pPr algn="ctr">
@@ -9588,7 +9380,7 @@
         <p:spPr>
           <a:xfrm>
             <a:off x="749808" y="1527048"/>
-            <a:ext cx="4946903" cy="2031365"/>
+            <a:ext cx="4946903" cy="2926079"/>
           </a:xfrm>
           <a:prstGeom prst="rect">
             <a:avLst/>
@@ -9609,10 +9401,8 @@
               </a:defRPr>
             </a:pPr>
             <a:r>
-              <a:rPr sz="1400"/>
               <a:t>1  Read and parse CSVs with explicit StructType schemas.</a:t>
             </a:r>
-            <a:endParaRPr sz="1400"/>
           </a:p>
           <a:p>
             <a:pPr>
@@ -9626,10 +9416,8 @@
               </a:defRPr>
             </a:pPr>
             <a:r>
-              <a:rPr sz="1400"/>
-              <a:t>2  Map-side composite deduplication (7 business keys).</a:t>
-            </a:r>
-            <a:endParaRPr sz="1400"/>
+              <a:t>2  Quality rules and business-key de-duplication → silver.</a:t>
+            </a:r>
           </a:p>
           <a:p>
             <a:pPr>
@@ -9643,10 +9431,8 @@
               </a:defRPr>
             </a:pPr>
             <a:r>
-              <a:rPr sz="1400"/>
-              <a:t>3  Window rolling stats (7-day mean, stddev, z-score).</a:t>
-            </a:r>
-            <a:endParaRPr sz="1400"/>
+              <a:t>3  Window features per series (≤ t) and targets (&gt; t).</a:t>
+            </a:r>
           </a:p>
           <a:p>
             <a:pPr>
@@ -9660,10 +9446,8 @@
               </a:defRPr>
             </a:pPr>
             <a:r>
-              <a:rPr sz="1400"/>
-              <a:t>4  Train MLlib Random Forest and save predictions.</a:t>
-            </a:r>
-            <a:endParaRPr sz="1400"/>
+              <a:t>4  Fit MLlib pipelines, choose on 2024, score the test once.</a:t>
+            </a:r>
           </a:p>
           <a:p>
             <a:pPr>
@@ -9677,10 +9461,8 @@
               </a:defRPr>
             </a:pPr>
             <a:r>
-              <a:rPr sz="1400"/>
-              <a:t>Partitions: Split work into 200 shuffle partitions; year directory pruning.</a:t>
-            </a:r>
-            <a:endParaRPr sz="1400"/>
+              <a:t>Partitions: 64 shuffle partitions (AQE coalesces); year= directory pruning.</a:t>
+            </a:r>
           </a:p>
           <a:p>
             <a:pPr>
@@ -9694,10 +9476,8 @@
               </a:defRPr>
             </a:pPr>
             <a:r>
-              <a:rPr sz="1400"/>
-              <a:t>Cache: Feature DataFrames cached in memory (prepTrain.cache()); unpersisted after training.</a:t>
-            </a:r>
-            <a:endParaRPr sz="1400"/>
+              <a:t>Scaling (measured): full 75.6M rows on 10 cores: W1 42.2 s, W2 65.9 s; speed-up 2.4× / 3.0× vs 1 core.</a:t>
+            </a:r>
           </a:p>
         </p:txBody>
       </p:sp>
@@ -9897,7 +9677,7 @@
           </a:fontRef>
         </p:style>
         <p:txBody>
-          <a:bodyPr tIns="54864" rtlCol="0" anchor="ctr"/>
+          <a:bodyPr rtlCol="0" anchor="ctr" tIns="54864"/>
           <a:lstStyle/>
           <a:p>
             <a:pPr algn="ctr">
@@ -9908,7 +9688,7 @@
               </a:defRPr>
             </a:pPr>
             <a:r>
-              <a:t>Stage 0: Parquet Read</a:t>
+              <a:t>Step 1: Parquet Read</a:t>
             </a:r>
           </a:p>
         </p:txBody>
@@ -9994,7 +9774,7 @@
           </a:fontRef>
         </p:style>
         <p:txBody>
-          <a:bodyPr tIns="54864" rtlCol="0" anchor="ctr"/>
+          <a:bodyPr rtlCol="0" anchor="ctr" tIns="54864"/>
           <a:lstStyle/>
           <a:p>
             <a:pPr algn="ctr">
@@ -10005,7 +9785,7 @@
               </a:defRPr>
             </a:pPr>
             <a:r>
-              <a:t>Stage 1: Filter &amp; Dedup</a:t>
+              <a:t>Step 2: Harmonise &amp; Filter</a:t>
             </a:r>
           </a:p>
         </p:txBody>
@@ -10091,7 +9871,7 @@
           </a:fontRef>
         </p:style>
         <p:txBody>
-          <a:bodyPr tIns="54864" rtlCol="0" anchor="ctr"/>
+          <a:bodyPr rtlCol="0" anchor="ctr" tIns="54864"/>
           <a:lstStyle/>
           <a:p>
             <a:pPr algn="ctr">
@@ -10102,7 +9882,7 @@
               </a:defRPr>
             </a:pPr>
             <a:r>
-              <a:t>Stage 2: Window Shuffle</a:t>
+              <a:t>Step 3: Window Shuffle</a:t>
             </a:r>
           </a:p>
         </p:txBody>
@@ -10188,7 +9968,7 @@
           </a:fontRef>
         </p:style>
         <p:txBody>
-          <a:bodyPr tIns="54864" rtlCol="0" anchor="ctr"/>
+          <a:bodyPr rtlCol="0" anchor="ctr" tIns="54864"/>
           <a:lstStyle/>
           <a:p>
             <a:pPr algn="ctr">
@@ -10199,7 +9979,7 @@
               </a:defRPr>
             </a:pPr>
             <a:r>
-              <a:t>Stage 3: Feature Vector</a:t>
+              <a:t>Step 4: Features &amp; Targets</a:t>
             </a:r>
           </a:p>
         </p:txBody>
@@ -10285,7 +10065,7 @@
           </a:fontRef>
         </p:style>
         <p:txBody>
-          <a:bodyPr tIns="54864" rtlCol="0" anchor="ctr"/>
+          <a:bodyPr rtlCol="0" anchor="ctr" tIns="54864"/>
           <a:lstStyle/>
           <a:p>
             <a:pPr algn="ctr">
@@ -10296,7 +10076,7 @@
               </a:defRPr>
             </a:pPr>
             <a:r>
-              <a:t>Stage 4: Model Fit</a:t>
+              <a:t>Step 5: Model Fit / Score</a:t>
             </a:r>
           </a:p>
         </p:txBody>
@@ -10310,7 +10090,7 @@
         <p:spPr>
           <a:xfrm>
             <a:off x="8412480" y="2103120"/>
-            <a:ext cx="3017520" cy="1599565"/>
+            <a:ext cx="3017520" cy="2011680"/>
           </a:xfrm>
           <a:prstGeom prst="rect">
             <a:avLst/>
@@ -10331,30 +10111,18 @@
               </a:defRPr>
             </a:pPr>
             <a:r>
-              <a:rPr sz="1400"/>
               <a:t>Arrows show stage dependencies.</a:t>
             </a:r>
-            <a:br>
-              <a:rPr sz="1400"/>
-            </a:br>
-            <a:br>
-              <a:rPr sz="1400"/>
-            </a:br>
-            <a:r>
-              <a:rPr sz="1400"/>
+            <a:br/>
+            <a:br/>
+            <a:r>
               <a:t>Wide transformations create shuffle boundaries.</a:t>
             </a:r>
-            <a:br>
-              <a:rPr sz="1400"/>
-            </a:br>
-            <a:br>
-              <a:rPr sz="1400"/>
-            </a:br>
-            <a:r>
-              <a:rPr sz="1400"/>
-              <a:t>An actual feature run completed across 13 distinct stages.</a:t>
-            </a:r>
-            <a:endParaRPr sz="1400"/>
+            <a:br/>
+            <a:br/>
+            <a:r>
+              <a:t>Exact stage counts are read from the Spark UI for each run.</a:t>
+            </a:r>
           </a:p>
         </p:txBody>
       </p:sp>
@@ -10525,7 +10293,7 @@
 </file>
 
 <file path=ppt/slides/slide6.xml><?xml version="1.0" encoding="utf-8"?>
-<p:sld xmlns:a="http://schemas.openxmlformats.org/drawingml/2006/main" xmlns:r="http://schemas.openxmlformats.org/officeDocument/2006/relationships" xmlns:p="http://schemas.openxmlformats.org/presentationml/2006/main">
+<p:sld xmlns:a="http://schemas.openxmlformats.org/drawingml/2006/main" xmlns:p="http://schemas.openxmlformats.org/presentationml/2006/main" xmlns:r="http://schemas.openxmlformats.org/officeDocument/2006/relationships">
   <p:cSld>
     <p:spTree>
       <p:nvGrpSpPr>
@@ -10613,7 +10381,7 @@
           </a:fontRef>
         </p:style>
         <p:txBody>
-          <a:bodyPr wrap="square" tIns="73152" rtlCol="0" anchor="ctr"/>
+          <a:bodyPr rtlCol="0" anchor="ctr" wrap="square" tIns="73152"/>
           <a:lstStyle/>
           <a:p>
             <a:pPr algn="ctr">
@@ -10665,7 +10433,7 @@
           </a:fontRef>
         </p:style>
         <p:txBody>
-          <a:bodyPr wrap="square" tIns="73152" rtlCol="0" anchor="ctr"/>
+          <a:bodyPr rtlCol="0" anchor="ctr" wrap="square" tIns="73152"/>
           <a:lstStyle/>
           <a:p>
             <a:pPr algn="ctr">
@@ -10717,7 +10485,7 @@
           </a:fontRef>
         </p:style>
         <p:txBody>
-          <a:bodyPr wrap="square" tIns="73152" rtlCol="0" anchor="ctr"/>
+          <a:bodyPr rtlCol="0" anchor="ctr" wrap="square" tIns="73152"/>
           <a:lstStyle/>
           <a:p>
             <a:pPr algn="ctr">
@@ -10900,7 +10668,7 @@
         <p:spPr>
           <a:xfrm>
             <a:off x="749808" y="1527048"/>
-            <a:ext cx="5266944" cy="2538730"/>
+            <a:ext cx="5266944" cy="2926079"/>
           </a:xfrm>
           <a:prstGeom prst="rect">
             <a:avLst/>
@@ -10921,93 +10689,42 @@
               </a:defRPr>
             </a:pPr>
             <a:r>
-              <a:rPr sz="1100"/>
-              <a:t>// 1. Resilient Date Parser with Safe Coalescing</a:t>
-            </a:r>
-            <a:br>
-              <a:rPr sz="1100"/>
-            </a:br>
-            <a:r>
-              <a:rPr sz="1100"/>
-              <a:t>val parseDate = coalesce(</a:t>
-            </a:r>
-            <a:br>
-              <a:rPr sz="1100"/>
-            </a:br>
-            <a:r>
-              <a:rPr sz="1100"/>
-              <a:t>  try_to_date(col("Reported Date"), "dd MMM yyyy"),</a:t>
-            </a:r>
-            <a:br>
-              <a:rPr sz="1100"/>
-            </a:br>
-            <a:r>
-              <a:rPr sz="1100"/>
-              <a:t>  try_to_date(col("Reported Date"), "yyyy-MM-dd")</a:t>
-            </a:r>
-            <a:br>
-              <a:rPr sz="1100"/>
-            </a:br>
-            <a:r>
-              <a:rPr sz="1100"/>
-              <a:t>)</a:t>
-            </a:r>
-            <a:br>
-              <a:rPr sz="1100"/>
-            </a:br>
-            <a:br>
-              <a:rPr sz="1100"/>
-            </a:br>
-            <a:r>
-              <a:rPr sz="1100"/>
-              <a:t>// 2. Map-Side Composite Business Key Deduplication</a:t>
-            </a:r>
-            <a:br>
-              <a:rPr sz="1100"/>
-            </a:br>
-            <a:r>
-              <a:rPr sz="1100"/>
-              <a:t>val w = Window.partitionBy("state", "market", "commodity", "date")</a:t>
-            </a:r>
-            <a:br>
-              <a:rPr sz="1100"/>
-            </a:br>
-            <a:r>
-              <a:rPr sz="1100"/>
-              <a:t>  .orderBy(col("is_valid").desc, col("price_spread").desc)</a:t>
-            </a:r>
-            <a:br>
-              <a:rPr sz="1100"/>
-            </a:br>
-            <a:r>
-              <a:rPr sz="1100"/>
-              <a:t>val dedup = raw.withColumn("rk", row_number().over(w)).filter("rk = 1")</a:t>
-            </a:r>
-            <a:br>
-              <a:rPr sz="1100"/>
-            </a:br>
-            <a:br>
-              <a:rPr sz="1100"/>
-            </a:br>
-            <a:r>
-              <a:rPr sz="1100"/>
-              <a:t>// 3. Stateful Real-Time Windowing in Spark Streaming</a:t>
-            </a:r>
-            <a:br>
-              <a:rPr sz="1100"/>
-            </a:br>
-            <a:r>
-              <a:rPr sz="1100"/>
-              <a:t>parsedStream.groupByKey(e =&gt; MarketEntity(e.state, e.market, e.commodity))</a:t>
-            </a:r>
-            <a:br>
-              <a:rPr sz="1100"/>
-            </a:br>
-            <a:r>
-              <a:rPr sz="1100"/>
-              <a:t>  .flatMapGroupsWithState(OutputMode.Append, GroupStateTimeout.NoTimeout)(updateState)</a:t>
-            </a:r>
-            <a:endParaRPr sz="1100"/>
+              <a:t>// 1. Non-fatal date parsing (Readers.scala)</a:t>
+            </a:r>
+            <a:br/>
+            <a:r>
+              <a:t>expr("try_to_date(trim(Arrival_Date), 'yyyy-MM-dd')")</a:t>
+            </a:r>
+            <a:br/>
+            <a:br/>
+            <a:r>
+              <a:t>// 2. Business-key de-duplication (Deduplicate.scala)</a:t>
+            </a:r>
+            <a:br/>
+            <a:r>
+              <a:t>val w = Window.partitionBy(DataQuality.businessKey.map(col): _*)</a:t>
+            </a:r>
+            <a:br/>
+            <a:r>
+              <a:t>  .orderBy(/* deterministic quality order */)</a:t>
+            </a:r>
+            <a:br/>
+            <a:r>
+              <a:t>df.withColumn("_rn", row_number().over(w))</a:t>
+            </a:r>
+            <a:br/>
+            <a:br/>
+            <a:r>
+              <a:t>// 3. Leakage-safe features (forecast/Features.scala)</a:t>
+            </a:r>
+            <a:br/>
+            <a:r>
+              <a:t>def days(lo: Long, hi: Long) = byEntity.rangeBetween(lo, hi)</a:t>
+            </a:r>
+            <a:br/>
+            <a:r>
+              <a:t>.withColumn("mean30", avg(lp).over(days(-29, 0)))  // ends at t</a:t>
+            </a:r>
           </a:p>
         </p:txBody>
       </p:sp>
@@ -11143,7 +10860,7 @@
         <p:spPr>
           <a:xfrm>
             <a:off x="6601968" y="1527048"/>
-            <a:ext cx="4809744" cy="2769870"/>
+            <a:ext cx="4809744" cy="2926079"/>
           </a:xfrm>
           <a:prstGeom prst="rect">
             <a:avLst/>
@@ -11164,10 +10881,8 @@
               </a:defRPr>
             </a:pPr>
             <a:r>
-              <a:rPr sz="1600"/>
               <a:t>• Read CSV with fixed column types and explicit StructType schemas.</a:t>
             </a:r>
-            <a:endParaRPr sz="1600"/>
           </a:p>
           <a:p>
             <a:pPr>
@@ -11181,10 +10896,8 @@
               </a:defRPr>
             </a:pPr>
             <a:r>
-              <a:rPr sz="1600"/>
-              <a:t>• Non-fatal date parsing prevents corrupted date strings from crashing jobs.</a:t>
-            </a:r>
-            <a:endParaRPr sz="1600"/>
+              <a:t>• Non-fatal date parsing: a malformed date becomes null, not a crash.</a:t>
+            </a:r>
           </a:p>
           <a:p>
             <a:pPr>
@@ -11198,10 +10911,8 @@
               </a:defRPr>
             </a:pPr>
             <a:r>
-              <a:rPr sz="1600"/>
-              <a:t>• Composite key deduplication avoids full-row distinct() hash OOM.</a:t>
-            </a:r>
-            <a:endParaRPr sz="1600"/>
+              <a:t>• Deterministic row_number() keeps one reproducible row per business key.</a:t>
+            </a:r>
           </a:p>
           <a:p>
             <a:pPr>
@@ -11215,10 +10926,8 @@
               </a:defRPr>
             </a:pPr>
             <a:r>
-              <a:rPr sz="1600"/>
-              <a:t>• Window rolling aggregations compute 7-day volatility and z-scores.</a:t>
-            </a:r>
-            <a:endParaRPr sz="1600"/>
+              <a:t>• Feature windows end at the current report; targets start after it; a perturbation test enforces this.</a:t>
+            </a:r>
           </a:p>
           <a:p>
             <a:pPr>
@@ -11232,10 +10941,8 @@
               </a:defRPr>
             </a:pPr>
             <a:r>
-              <a:rPr sz="1600"/>
-              <a:t>• Stateful streaming maintains per-market rolling state in Kafka.</a:t>
-            </a:r>
-            <a:endParaRPr sz="1600"/>
+              <a:t>• Batch and streaming share one canonicalisation function.</a:t>
+            </a:r>
           </a:p>
         </p:txBody>
       </p:sp>
@@ -11371,7 +11078,7 @@
         <p:spPr>
           <a:xfrm>
             <a:off x="777240" y="5148072"/>
-            <a:ext cx="10607040" cy="645795"/>
+            <a:ext cx="10607040" cy="905256"/>
           </a:xfrm>
           <a:prstGeom prst="rect">
             <a:avLst/>
@@ -11392,10 +11099,8 @@
               </a:defRPr>
             </a:pPr>
             <a:r>
-              <a:rPr sz="1400"/>
-              <a:t>RealDataReplay.scala reads 15,000 real market records and sends them to Kafka topic 'agri-market-real-replay'. Spark Structured Streaming reads micro-batches from Kafka, maintains 7-day rolling state via flatMapGroupsWithState, and calculates live anomaly scores. Checkpoints record streaming progress in HDFS.</a:t>
-            </a:r>
-            <a:endParaRPr sz="1400"/>
+              <a:t>Reports go to Kafka topic agri.prices.v1 (6 partitions). PriceEventStream writes bronze (raw + offsets), quarantines invalid messages before a 10-day watermark, drops re-sends by event_id, and writes silver and alerts. Checkpointed offsets give effectively-once output per offset range (end-to-end exactly-once is not claimed).</a:t>
+            </a:r>
           </a:p>
         </p:txBody>
       </p:sp>
@@ -11408,7 +11113,7 @@
 </file>
 
 <file path=ppt/slides/slide7.xml><?xml version="1.0" encoding="utf-8"?>
-<p:sld xmlns:a="http://schemas.openxmlformats.org/drawingml/2006/main" xmlns:r="http://schemas.openxmlformats.org/officeDocument/2006/relationships" xmlns:p="http://schemas.openxmlformats.org/presentationml/2006/main">
+<p:sld xmlns:a="http://schemas.openxmlformats.org/drawingml/2006/main" xmlns:p="http://schemas.openxmlformats.org/presentationml/2006/main" xmlns:r="http://schemas.openxmlformats.org/officeDocument/2006/relationships">
   <p:cSld>
     <p:spTree>
       <p:nvGrpSpPr>
@@ -11496,7 +11201,7 @@
           </a:fontRef>
         </p:style>
         <p:txBody>
-          <a:bodyPr wrap="square" tIns="73152" rtlCol="0" anchor="ctr"/>
+          <a:bodyPr rtlCol="0" anchor="ctr" wrap="square" tIns="73152"/>
           <a:lstStyle/>
           <a:p>
             <a:pPr algn="ctr">
@@ -11548,7 +11253,7 @@
           </a:fontRef>
         </p:style>
         <p:txBody>
-          <a:bodyPr wrap="square" tIns="73152" rtlCol="0" anchor="ctr"/>
+          <a:bodyPr rtlCol="0" anchor="ctr" wrap="square" tIns="73152"/>
           <a:lstStyle/>
           <a:p>
             <a:pPr algn="ctr">
@@ -11600,7 +11305,7 @@
           </a:fontRef>
         </p:style>
         <p:txBody>
-          <a:bodyPr wrap="square" tIns="73152" rtlCol="0" anchor="ctr"/>
+          <a:bodyPr rtlCol="0" anchor="ctr" wrap="square" tIns="73152"/>
           <a:lstStyle/>
           <a:p>
             <a:pPr algn="ctr">
@@ -11769,7 +11474,7 @@
               </a:defRPr>
             </a:pPr>
             <a:r>
-              <a:t>Two versions of the market model</a:t>
+              <a:t>Baselines and models</a:t>
             </a:r>
           </a:p>
         </p:txBody>
@@ -11783,7 +11488,7 @@
         <p:spPr>
           <a:xfrm>
             <a:off x="749808" y="1527048"/>
-            <a:ext cx="4946903" cy="2410460"/>
+            <a:ext cx="4946903" cy="2926079"/>
           </a:xfrm>
           <a:prstGeom prst="rect">
             <a:avLst/>
@@ -11804,10 +11509,8 @@
               </a:defRPr>
             </a:pPr>
             <a:r>
-              <a:rPr sz="1400"/>
-              <a:t>1  Task A: Next-Day Anomaly Forecasting</a:t>
-            </a:r>
-            <a:endParaRPr sz="1400"/>
+              <a:t>1  Baselines</a:t>
+            </a:r>
           </a:p>
           <a:p>
             <a:pPr>
@@ -11821,24 +11524,16 @@
               </a:defRPr>
             </a:pPr>
             <a:r>
-              <a:rPr sz="1400"/>
-              <a:t>• Target: lead(z_score, 1) &gt; 2.0 (predict tomorrow's spike).</a:t>
-            </a:r>
-            <a:br>
-              <a:rPr sz="1400"/>
-            </a:br>
-            <a:r>
-              <a:rPr sz="1400"/>
-              <a:t>• Features: 9 price features (lags, intraday ranges, rolling stats).</a:t>
-            </a:r>
-            <a:br>
-              <a:rPr sz="1400"/>
-            </a:br>
-            <a:r>
-              <a:rPr sz="1400"/>
-              <a:t>• Evaluates advance warning capability.</a:t>
-            </a:r>
-            <a:endParaRPr sz="1400"/>
+              <a:t>• Persistence (last report), moving averages, seasonal naive.</a:t>
+            </a:r>
+            <a:br/>
+            <a:r>
+              <a:t>• Target: log return to a report strictly after the origin.</a:t>
+            </a:r>
+            <a:br/>
+            <a:r>
+              <a:t>• Horizons: next report, 3, 7 and 14 days.</a:t>
+            </a:r>
           </a:p>
           <a:p>
             <a:pPr>
@@ -11852,10 +11547,8 @@
               </a:defRPr>
             </a:pPr>
             <a:r>
-              <a:rPr sz="1400"/>
-              <a:t>2  Task B: Real-Time Transaction Screening</a:t>
-            </a:r>
-            <a:endParaRPr sz="1400"/>
+              <a:t>2  Spark MLlib pipelines</a:t>
+            </a:r>
           </a:p>
           <a:p>
             <a:pPr>
@@ -11869,24 +11562,16 @@
               </a:defRPr>
             </a:pPr>
             <a:r>
-              <a:rPr sz="1400"/>
-              <a:t>• Target: |z_score| &gt; 2.0 on current transaction.</a:t>
-            </a:r>
-            <a:br>
-              <a:rPr sz="1400"/>
-            </a:br>
-            <a:r>
-              <a:rPr sz="1400"/>
-              <a:t>• Features: 9 features + contemporaneous price spread ratios.</a:t>
-            </a:r>
-            <a:br>
-              <a:rPr sz="1400"/>
-            </a:br>
-            <a:r>
-              <a:rPr sz="1400"/>
-              <a:t>• Evaluates live streaming Kafka screening.</a:t>
-            </a:r>
-            <a:endParaRPr sz="1400"/>
+              <a:t>• Linear regression, random forest, gradient-boosted trees.</a:t>
+            </a:r>
+            <a:br/>
+            <a:r>
+              <a:t>• One global model per horizon, fitted on training rows only.</a:t>
+            </a:r>
+            <a:br/>
+            <a:r>
+              <a:t>• 80% split-conformal intervals calibrated on 2024.</a:t>
+            </a:r>
           </a:p>
           <a:p>
             <a:pPr>
@@ -11900,10 +11585,8 @@
               </a:defRPr>
             </a:pPr>
             <a:r>
-              <a:rPr sz="1400"/>
-              <a:t>Both models use Spark MLlib RandomForestClassifier (100 Trees).</a:t>
-            </a:r>
-            <a:endParaRPr sz="1400"/>
+              <a:t>Selected: GBT, absolute loss (next, 3 d); random forest, 60 trees, depth 10 (7, 14 d).</a:t>
+            </a:r>
           </a:p>
         </p:txBody>
       </p:sp>
@@ -12039,7 +11722,7 @@
         <p:spPr>
           <a:xfrm>
             <a:off x="6464807" y="1527048"/>
-            <a:ext cx="4946903" cy="2105660"/>
+            <a:ext cx="4946903" cy="2926079"/>
           </a:xfrm>
           <a:prstGeom prst="rect">
             <a:avLst/>
@@ -12060,10 +11743,8 @@
               </a:defRPr>
             </a:pPr>
             <a:r>
-              <a:rPr sz="1400"/>
-              <a:t>Strict Chronological Split (Zero Data Leakage):</a:t>
-            </a:r>
-            <a:endParaRPr sz="1400"/>
+              <a:t>Chronological split (purged on target dates):</a:t>
+            </a:r>
           </a:p>
           <a:p>
             <a:pPr>
@@ -12077,24 +11758,16 @@
               </a:defRPr>
             </a:pPr>
             <a:r>
-              <a:rPr sz="1400"/>
-              <a:t>• Earlier 70% (&lt; 2024): 721,668 rows to train models.</a:t>
-            </a:r>
-            <a:br>
-              <a:rPr sz="1400"/>
-            </a:br>
-            <a:r>
-              <a:rPr sz="1400"/>
-              <a:t>• 2024 Validation: 49,721 rows for threshold &amp; depth tuning.</a:t>
-            </a:r>
-            <a:br>
-              <a:rPr sz="1400"/>
-            </a:br>
-            <a:r>
-              <a:rPr sz="1400"/>
-              <a:t>• Later 30% (2025+): 48,354 untouched rows to test models.</a:t>
-            </a:r>
-            <a:endParaRPr sz="1400"/>
+              <a:t>• Train: origins 2016-01-01 .. 2023-12-31.</a:t>
+            </a:r>
+            <a:br/>
+            <a:r>
+              <a:t>• Validation: 2024, model choice and conformal calibration.</a:t>
+            </a:r>
+            <a:br/>
+            <a:r>
+              <a:t>• Test: 2025-01-01 .. 2026-04-20, scored once.</a:t>
+            </a:r>
           </a:p>
           <a:p>
             <a:pPr>
@@ -12108,10 +11781,8 @@
               </a:defRPr>
             </a:pPr>
             <a:r>
-              <a:rPr sz="1400"/>
-              <a:t>Hyperparameter Search:</a:t>
-            </a:r>
-            <a:endParaRPr sz="1400"/>
+              <a:t>Then, frozen models (no refitting):</a:t>
+            </a:r>
           </a:p>
           <a:p>
             <a:pPr>
@@ -12125,24 +11796,12 @@
               </a:defRPr>
             </a:pPr>
             <a:r>
-              <a:rPr sz="1400"/>
-              <a:t>• Tested tree depths 6, 8, 12, 14; selected depth 12–14.</a:t>
-            </a:r>
-            <a:br>
-              <a:rPr sz="1400"/>
-            </a:br>
-            <a:r>
-              <a:rPr sz="1400"/>
-              <a:t>• 100 parallel trees; 128 continuous feature bins.</a:t>
-            </a:r>
-            <a:br>
-              <a:rPr sz="1400"/>
-            </a:br>
-            <a:r>
-              <a:rPr sz="1400"/>
-              <a:t>• Class Weighting (w=1.2) balances 15.6% anomaly prevalence.</a:t>
-            </a:r>
-            <a:endParaRPr sz="1400"/>
+              <a:t>• Same test period on complete official data.</a:t>
+            </a:r>
+            <a:br/>
+            <a:r>
+              <a:t>• Prospective 2026-04-22 → 2026-10-22: data that did not exist in the archive.</a:t>
+            </a:r>
           </a:p>
         </p:txBody>
       </p:sp>
@@ -12278,7 +11937,7 @@
         <p:spPr>
           <a:xfrm>
             <a:off x="777240" y="5148072"/>
-            <a:ext cx="10607040" cy="430530"/>
+            <a:ext cx="10607040" cy="905256"/>
           </a:xfrm>
           <a:prstGeom prst="rect">
             <a:avLst/>
@@ -12299,10 +11958,8 @@
               </a:defRPr>
             </a:pPr>
             <a:r>
-              <a:rPr sz="1400"/>
-              <a:t>Random k-fold cross-validation causes future market information to leak into past models. Splitting chronologically (&lt;2024 train vs 2025+ test) strictly tests the model on unseen future market periods, replicating true production deployment for agricultural markets.</a:t>
-            </a:r>
-            <a:endParaRPr sz="1400"/>
+              <a:t>Random k-fold cross-validation lets future market information leak into training. Splitting chronologically and scoring the test once tests the models on genuinely later periods, as in deployment; the prospective check then uses months that did not exist when the models were trained.</a:t>
+            </a:r>
           </a:p>
         </p:txBody>
       </p:sp>
@@ -12315,7 +11972,7 @@
 </file>
 
 <file path=ppt/slides/slide8.xml><?xml version="1.0" encoding="utf-8"?>
-<p:sld xmlns:a="http://schemas.openxmlformats.org/drawingml/2006/main" xmlns:r="http://schemas.openxmlformats.org/officeDocument/2006/relationships" xmlns:p="http://schemas.openxmlformats.org/presentationml/2006/main">
+<p:sld xmlns:a="http://schemas.openxmlformats.org/drawingml/2006/main" xmlns:p="http://schemas.openxmlformats.org/presentationml/2006/main" xmlns:r="http://schemas.openxmlformats.org/officeDocument/2006/relationships">
   <p:cSld>
     <p:spTree>
       <p:nvGrpSpPr>
@@ -12403,7 +12060,7 @@
           </a:fontRef>
         </p:style>
         <p:txBody>
-          <a:bodyPr wrap="square" tIns="73152" rtlCol="0" anchor="ctr"/>
+          <a:bodyPr rtlCol="0" anchor="ctr" wrap="square" tIns="73152"/>
           <a:lstStyle/>
           <a:p>
             <a:pPr algn="ctr">
@@ -12455,7 +12112,7 @@
           </a:fontRef>
         </p:style>
         <p:txBody>
-          <a:bodyPr wrap="square" tIns="73152" rtlCol="0" anchor="ctr"/>
+          <a:bodyPr rtlCol="0" anchor="ctr" wrap="square" tIns="73152"/>
           <a:lstStyle/>
           <a:p>
             <a:pPr algn="ctr">
@@ -12507,7 +12164,7 @@
           </a:fontRef>
         </p:style>
         <p:txBody>
-          <a:bodyPr wrap="square" tIns="73152" rtlCol="0" anchor="ctr"/>
+          <a:bodyPr rtlCol="0" anchor="ctr" wrap="square" tIns="73152"/>
           <a:lstStyle/>
           <a:p>
             <a:pPr algn="ctr">
@@ -12532,7 +12189,7 @@
         <p:spPr>
           <a:xfrm>
             <a:off x="548640" y="292608"/>
-            <a:ext cx="11094415" cy="368935"/>
+            <a:ext cx="11094415" cy="594360"/>
           </a:xfrm>
           <a:prstGeom prst="rect">
             <a:avLst/>
@@ -12553,10 +12210,8 @@
               </a:defRPr>
             </a:pPr>
             <a:r>
-              <a:rPr sz="2400"/>
-              <a:t>7. Results for Both Tasks</a:t>
-            </a:r>
-            <a:endParaRPr sz="2400"/>
+              <a:t>7. Results</a:t>
+            </a:r>
           </a:p>
         </p:txBody>
       </p:sp>
@@ -12678,7 +12333,7 @@
               </a:defRPr>
             </a:pPr>
             <a:r>
-              <a:t>Model results — untouched 2025+ test set (48,354 records)</a:t>
+              <a:t>Forecasting — test 2025-01-01 .. 2026-04-20 (relative MAE vs persistence; lower is better)</a:t>
             </a:r>
           </a:p>
         </p:txBody>
@@ -12747,11 +12402,11 @@
                         </a:defRPr>
                       </a:pPr>
                       <a:r>
-                        <a:t>Model / Configuration</a:t>
+                        <a:t>Horizon (selected model)</a:t>
                       </a:r>
                     </a:p>
                   </a:txBody>
-                  <a:tcPr anchor="ctr">
+                  <a:tcPr anchor="ctr" marL="91440" marR="91440">
                     <a:solidFill>
                       <a:srgbClr val="E4EAF6"/>
                     </a:solidFill>
@@ -12770,11 +12425,11 @@
                         </a:defRPr>
                       </a:pPr>
                       <a:r>
-                        <a:t>Accuracy</a:t>
+                        <a:t>Persist. MAE ₹/q</a:t>
                       </a:r>
                     </a:p>
                   </a:txBody>
-                  <a:tcPr anchor="ctr">
+                  <a:tcPr anchor="ctr" marL="91440" marR="91440">
                     <a:solidFill>
                       <a:srgbClr val="E4EAF6"/>
                     </a:solidFill>
@@ -12793,11 +12448,11 @@
                         </a:defRPr>
                       </a:pPr>
                       <a:r>
-                        <a:t>Precision</a:t>
+                        <a:t>Model MAE ₹/q</a:t>
                       </a:r>
                     </a:p>
                   </a:txBody>
-                  <a:tcPr anchor="ctr">
+                  <a:tcPr anchor="ctr" marL="91440" marR="91440">
                     <a:solidFill>
                       <a:srgbClr val="E4EAF6"/>
                     </a:solidFill>
@@ -12816,11 +12471,11 @@
                         </a:defRPr>
                       </a:pPr>
                       <a:r>
-                        <a:t>Recall</a:t>
+                        <a:t>Rel. MAE</a:t>
                       </a:r>
                     </a:p>
                   </a:txBody>
-                  <a:tcPr anchor="ctr">
+                  <a:tcPr anchor="ctr" marL="91440" marR="91440">
                     <a:solidFill>
                       <a:srgbClr val="E4EAF6"/>
                     </a:solidFill>
@@ -12839,11 +12494,11 @@
                         </a:defRPr>
                       </a:pPr>
                       <a:r>
-                        <a:t>F1-Score</a:t>
+                        <a:t>80% cover.</a:t>
                       </a:r>
                     </a:p>
                   </a:txBody>
-                  <a:tcPr anchor="ctr">
+                  <a:tcPr anchor="ctr" marL="91440" marR="91440">
                     <a:solidFill>
                       <a:srgbClr val="E4EAF6"/>
                     </a:solidFill>
@@ -12862,11 +12517,11 @@
                         </a:defRPr>
                       </a:pPr>
                       <a:r>
-                        <a:t>FPR</a:t>
+                        <a:t>Frozen, 2026-04→10</a:t>
                       </a:r>
                     </a:p>
                   </a:txBody>
-                  <a:tcPr anchor="ctr">
+                  <a:tcPr anchor="ctr" marL="91440" marR="91440">
                     <a:solidFill>
                       <a:srgbClr val="E4EAF6"/>
                     </a:solidFill>
@@ -12887,11 +12542,11 @@
                         </a:defRPr>
                       </a:pPr>
                       <a:r>
-                        <a:t>Trivial Baseline (All Normal)</a:t>
+                        <a:t>Next report (GBT, abs. loss)</a:t>
                       </a:r>
                     </a:p>
                   </a:txBody>
-                  <a:tcPr anchor="ctr">
+                  <a:tcPr anchor="ctr" marL="91440" marR="91440">
                     <a:solidFill>
                       <a:srgbClr val="FFFFFF"/>
                     </a:solidFill>
@@ -12910,11 +12565,11 @@
                         </a:defRPr>
                       </a:pPr>
                       <a:r>
-                        <a:t>84.35%</a:t>
+                        <a:t>189.0</a:t>
                       </a:r>
                     </a:p>
                   </a:txBody>
-                  <a:tcPr anchor="ctr">
+                  <a:tcPr anchor="ctr" marL="91440" marR="91440">
                     <a:solidFill>
                       <a:srgbClr val="FFFFFF"/>
                     </a:solidFill>
@@ -12933,11 +12588,11 @@
                         </a:defRPr>
                       </a:pPr>
                       <a:r>
-                        <a:t>0.00%</a:t>
+                        <a:t>183.5</a:t>
                       </a:r>
                     </a:p>
                   </a:txBody>
-                  <a:tcPr anchor="ctr">
+                  <a:tcPr anchor="ctr" marL="91440" marR="91440">
                     <a:solidFill>
                       <a:srgbClr val="FFFFFF"/>
                     </a:solidFill>
@@ -12956,11 +12611,11 @@
                         </a:defRPr>
                       </a:pPr>
                       <a:r>
-                        <a:t>0.00%</a:t>
+                        <a:t>0.971</a:t>
                       </a:r>
                     </a:p>
                   </a:txBody>
-                  <a:tcPr anchor="ctr">
+                  <a:tcPr anchor="ctr" marL="91440" marR="91440">
                     <a:solidFill>
                       <a:srgbClr val="FFFFFF"/>
                     </a:solidFill>
@@ -12979,11 +12634,11 @@
                         </a:defRPr>
                       </a:pPr>
                       <a:r>
-                        <a:t>0.00%</a:t>
+                        <a:t>78.6%</a:t>
                       </a:r>
                     </a:p>
                   </a:txBody>
-                  <a:tcPr anchor="ctr">
+                  <a:tcPr anchor="ctr" marL="91440" marR="91440">
                     <a:solidFill>
                       <a:srgbClr val="FFFFFF"/>
                     </a:solidFill>
@@ -13002,11 +12657,11 @@
                         </a:defRPr>
                       </a:pPr>
                       <a:r>
-                        <a:t>—</a:t>
+                        <a:t>0.963</a:t>
                       </a:r>
                     </a:p>
                   </a:txBody>
-                  <a:tcPr anchor="ctr">
+                  <a:tcPr anchor="ctr" marL="91440" marR="91440">
                     <a:solidFill>
                       <a:srgbClr val="FFFFFF"/>
                     </a:solidFill>
@@ -13027,11 +12682,11 @@
                         </a:defRPr>
                       </a:pPr>
                       <a:r>
-                        <a:t>Task 1A: Next-Day Forecasting (w=1.2)</a:t>
+                        <a:t>3 days (GBT, abs. loss)</a:t>
                       </a:r>
                     </a:p>
                   </a:txBody>
-                  <a:tcPr anchor="ctr">
+                  <a:tcPr anchor="ctr" marL="91440" marR="91440">
                     <a:solidFill>
                       <a:srgbClr val="F5F8FD"/>
                     </a:solidFill>
@@ -13050,11 +12705,11 @@
                         </a:defRPr>
                       </a:pPr>
                       <a:r>
-                        <a:t>85.06%</a:t>
+                        <a:t>242.6</a:t>
                       </a:r>
                     </a:p>
                   </a:txBody>
-                  <a:tcPr anchor="ctr">
+                  <a:tcPr anchor="ctr" marL="91440" marR="91440">
                     <a:solidFill>
                       <a:srgbClr val="F5F8FD"/>
                     </a:solidFill>
@@ -13073,11 +12728,11 @@
                         </a:defRPr>
                       </a:pPr>
                       <a:r>
-                        <a:t>61.48%</a:t>
+                        <a:t>231.1</a:t>
                       </a:r>
                     </a:p>
                   </a:txBody>
-                  <a:tcPr anchor="ctr">
+                  <a:tcPr anchor="ctr" marL="91440" marR="91440">
                     <a:solidFill>
                       <a:srgbClr val="F5F8FD"/>
                     </a:solidFill>
@@ -13096,11 +12751,11 @@
                         </a:defRPr>
                       </a:pPr>
                       <a:r>
-                        <a:t>12.11%</a:t>
+                        <a:t>0.953</a:t>
                       </a:r>
                     </a:p>
                   </a:txBody>
-                  <a:tcPr anchor="ctr">
+                  <a:tcPr anchor="ctr" marL="91440" marR="91440">
                     <a:solidFill>
                       <a:srgbClr val="F5F8FD"/>
                     </a:solidFill>
@@ -13119,11 +12774,11 @@
                         </a:defRPr>
                       </a:pPr>
                       <a:r>
-                        <a:t>20.23%</a:t>
+                        <a:t>79.4%</a:t>
                       </a:r>
                     </a:p>
                   </a:txBody>
-                  <a:tcPr anchor="ctr">
+                  <a:tcPr anchor="ctr" marL="91440" marR="91440">
                     <a:solidFill>
                       <a:srgbClr val="F5F8FD"/>
                     </a:solidFill>
@@ -13142,11 +12797,11 @@
                         </a:defRPr>
                       </a:pPr>
                       <a:r>
-                        <a:t>1.41%</a:t>
+                        <a:t>0.955</a:t>
                       </a:r>
                     </a:p>
                   </a:txBody>
-                  <a:tcPr anchor="ctr">
+                  <a:tcPr anchor="ctr" marL="91440" marR="91440">
                     <a:solidFill>
                       <a:srgbClr val="F5F8FD"/>
                     </a:solidFill>
@@ -13167,11 +12822,11 @@
                         </a:defRPr>
                       </a:pPr>
                       <a:r>
-                        <a:t>Task 1B: Next-Day Forecasting (w=5.0)</a:t>
+                        <a:t>7 days (random forest)</a:t>
                       </a:r>
                     </a:p>
                   </a:txBody>
-                  <a:tcPr anchor="ctr">
+                  <a:tcPr anchor="ctr" marL="91440" marR="91440">
                     <a:solidFill>
                       <a:srgbClr val="FFFFFF"/>
                     </a:solidFill>
@@ -13190,11 +12845,11 @@
                         </a:defRPr>
                       </a:pPr>
                       <a:r>
-                        <a:t>72.54%</a:t>
+                        <a:t>308.8</a:t>
                       </a:r>
                     </a:p>
                   </a:txBody>
-                  <a:tcPr anchor="ctr">
+                  <a:tcPr anchor="ctr" marL="91440" marR="91440">
                     <a:solidFill>
                       <a:srgbClr val="FFFFFF"/>
                     </a:solidFill>
@@ -13213,11 +12868,11 @@
                         </a:defRPr>
                       </a:pPr>
                       <a:r>
-                        <a:t>28.06%</a:t>
+                        <a:t>289.7</a:t>
                       </a:r>
                     </a:p>
                   </a:txBody>
-                  <a:tcPr anchor="ctr">
+                  <a:tcPr anchor="ctr" marL="91440" marR="91440">
                     <a:solidFill>
                       <a:srgbClr val="FFFFFF"/>
                     </a:solidFill>
@@ -13236,11 +12891,11 @@
                         </a:defRPr>
                       </a:pPr>
                       <a:r>
-                        <a:t>48.25%</a:t>
+                        <a:t>0.938</a:t>
                       </a:r>
                     </a:p>
                   </a:txBody>
-                  <a:tcPr anchor="ctr">
+                  <a:tcPr anchor="ctr" marL="91440" marR="91440">
                     <a:solidFill>
                       <a:srgbClr val="FFFFFF"/>
                     </a:solidFill>
@@ -13259,11 +12914,11 @@
                         </a:defRPr>
                       </a:pPr>
                       <a:r>
-                        <a:t>35.48%</a:t>
+                        <a:t>80.0%</a:t>
                       </a:r>
                     </a:p>
                   </a:txBody>
-                  <a:tcPr anchor="ctr">
+                  <a:tcPr anchor="ctr" marL="91440" marR="91440">
                     <a:solidFill>
                       <a:srgbClr val="FFFFFF"/>
                     </a:solidFill>
@@ -13282,11 +12937,11 @@
                         </a:defRPr>
                       </a:pPr>
                       <a:r>
-                        <a:t>22.95%</a:t>
+                        <a:t>0.958</a:t>
                       </a:r>
                     </a:p>
                   </a:txBody>
-                  <a:tcPr anchor="ctr">
+                  <a:tcPr anchor="ctr" marL="91440" marR="91440">
                     <a:solidFill>
                       <a:srgbClr val="FFFFFF"/>
                     </a:solidFill>
@@ -13300,20 +12955,20 @@
                     <a:lstStyle/>
                     <a:p>
                       <a:pPr algn="l">
-                        <a:defRPr sz="1050" b="1">
+                        <a:defRPr sz="1050">
                           <a:solidFill>
-                            <a:srgbClr val="008232"/>
+                            <a:srgbClr val="141923"/>
                           </a:solidFill>
                         </a:defRPr>
                       </a:pPr>
                       <a:r>
-                        <a:t>Task 2: Real-Time Screening (Production)</a:t>
+                        <a:t>14 days (random forest)</a:t>
                       </a:r>
                     </a:p>
                   </a:txBody>
-                  <a:tcPr anchor="ctr">
+                  <a:tcPr anchor="ctr" marL="91440" marR="91440">
                     <a:solidFill>
-                      <a:srgbClr val="EBF7EE"/>
+                      <a:srgbClr val="F5F8FD"/>
                     </a:solidFill>
                   </a:tcPr>
                 </a:tc>
@@ -13323,20 +12978,20 @@
                     <a:lstStyle/>
                     <a:p>
                       <a:pPr algn="r">
-                        <a:defRPr sz="1050" b="1">
+                        <a:defRPr sz="1050">
                           <a:solidFill>
-                            <a:srgbClr val="008232"/>
+                            <a:srgbClr val="141923"/>
                           </a:solidFill>
                         </a:defRPr>
                       </a:pPr>
                       <a:r>
-                        <a:t>95.66%</a:t>
+                        <a:t>397.0</a:t>
                       </a:r>
                     </a:p>
                   </a:txBody>
-                  <a:tcPr anchor="ctr">
+                  <a:tcPr anchor="ctr" marL="91440" marR="91440">
                     <a:solidFill>
-                      <a:srgbClr val="EBF7EE"/>
+                      <a:srgbClr val="F5F8FD"/>
                     </a:solidFill>
                   </a:tcPr>
                 </a:tc>
@@ -13346,20 +13001,20 @@
                     <a:lstStyle/>
                     <a:p>
                       <a:pPr algn="r">
-                        <a:defRPr sz="1050" b="1">
+                        <a:defRPr sz="1050">
                           <a:solidFill>
-                            <a:srgbClr val="008232"/>
+                            <a:srgbClr val="141923"/>
                           </a:solidFill>
                         </a:defRPr>
                       </a:pPr>
                       <a:r>
-                        <a:t>86.55%</a:t>
+                        <a:t>366.4</a:t>
                       </a:r>
                     </a:p>
                   </a:txBody>
-                  <a:tcPr anchor="ctr">
+                  <a:tcPr anchor="ctr" marL="91440" marR="91440">
                     <a:solidFill>
-                      <a:srgbClr val="EBF7EE"/>
+                      <a:srgbClr val="F5F8FD"/>
                     </a:solidFill>
                   </a:tcPr>
                 </a:tc>
@@ -13369,20 +13024,20 @@
                     <a:lstStyle/>
                     <a:p>
                       <a:pPr algn="r">
-                        <a:defRPr sz="1050" b="1">
+                        <a:defRPr sz="1050">
                           <a:solidFill>
-                            <a:srgbClr val="008232"/>
+                            <a:srgbClr val="141923"/>
                           </a:solidFill>
                         </a:defRPr>
                       </a:pPr>
                       <a:r>
-                        <a:t>85.47%</a:t>
+                        <a:t>0.923</a:t>
                       </a:r>
                     </a:p>
                   </a:txBody>
-                  <a:tcPr anchor="ctr">
+                  <a:tcPr anchor="ctr" marL="91440" marR="91440">
                     <a:solidFill>
-                      <a:srgbClr val="EBF7EE"/>
+                      <a:srgbClr val="F5F8FD"/>
                     </a:solidFill>
                   </a:tcPr>
                 </a:tc>
@@ -13392,20 +13047,20 @@
                     <a:lstStyle/>
                     <a:p>
                       <a:pPr algn="r">
-                        <a:defRPr sz="1050" b="1">
+                        <a:defRPr sz="1050">
                           <a:solidFill>
-                            <a:srgbClr val="008232"/>
+                            <a:srgbClr val="141923"/>
                           </a:solidFill>
                         </a:defRPr>
                       </a:pPr>
                       <a:r>
-                        <a:t>86.01%</a:t>
+                        <a:t>80.5%</a:t>
                       </a:r>
                     </a:p>
                   </a:txBody>
-                  <a:tcPr anchor="ctr">
+                  <a:tcPr anchor="ctr" marL="91440" marR="91440">
                     <a:solidFill>
-                      <a:srgbClr val="EBF7EE"/>
+                      <a:srgbClr val="F5F8FD"/>
                     </a:solidFill>
                   </a:tcPr>
                 </a:tc>
@@ -13415,20 +13070,20 @@
                     <a:lstStyle/>
                     <a:p>
                       <a:pPr algn="r">
-                        <a:defRPr sz="1050" b="1">
+                        <a:defRPr sz="1050">
                           <a:solidFill>
-                            <a:srgbClr val="008232"/>
+                            <a:srgbClr val="141923"/>
                           </a:solidFill>
                         </a:defRPr>
                       </a:pPr>
                       <a:r>
-                        <a:t>2.46%</a:t>
+                        <a:t>0.952</a:t>
                       </a:r>
                     </a:p>
                   </a:txBody>
-                  <a:tcPr anchor="ctr">
+                  <a:tcPr anchor="ctr" marL="91440" marR="91440">
                     <a:solidFill>
-                      <a:srgbClr val="EBF7EE"/>
+                      <a:srgbClr val="F5F8FD"/>
                     </a:solidFill>
                   </a:tcPr>
                 </a:tc>
@@ -13555,7 +13210,7 @@
               </a:defRPr>
             </a:pPr>
             <a:r>
-              <a:t>What the ML results mean</a:t>
+              <a:t>What the results mean</a:t>
             </a:r>
           </a:p>
         </p:txBody>
@@ -13569,7 +13224,7 @@
         <p:spPr>
           <a:xfrm>
             <a:off x="749808" y="4133087"/>
-            <a:ext cx="4946903" cy="1877060"/>
+            <a:ext cx="4946903" cy="2057400"/>
           </a:xfrm>
           <a:prstGeom prst="rect">
             <a:avLst/>
@@ -13590,10 +13245,8 @@
               </a:defRPr>
             </a:pPr>
             <a:r>
-              <a:rPr sz="1400"/>
-              <a:t>• Production Model achieves 95.66% accuracy and 86.01% F1-score.</a:t>
-            </a:r>
-            <a:endParaRPr sz="1400"/>
+              <a:t>• 3–8% lower error than persistence; Diebold–Mariano p ≤ 1.3e-22 at every horizon.</a:t>
+            </a:r>
           </a:p>
           <a:p>
             <a:pPr>
@@ -13607,10 +13260,8 @@
               </a:defRPr>
             </a:pPr>
             <a:r>
-              <a:rPr sz="1400"/>
-              <a:t>• High Actionability: 86.55% precision ensures mandi officials and farmers can trust alerts without false panic.</a:t>
-            </a:r>
-            <a:endParaRPr sz="1400"/>
+              <a:t>• Better than persistence on 58.5–76.4% of series; 80% intervals cover 78.6–80.5%.</a:t>
+            </a:r>
           </a:p>
           <a:p>
             <a:pPr>
@@ -13624,10 +13275,8 @@
               </a:defRPr>
             </a:pPr>
             <a:r>
-              <a:rPr sz="1400"/>
-              <a:t>• Ultra-Low False Alarms: 2.46% False Positive Rate prevents disruptive regulatory over-reaction.</a:t>
-            </a:r>
-            <a:endParaRPr sz="1400"/>
+              <a:t>• Cards (7 d): WATCH 98.5% of days; HOLD 0.5% (hit 80.0%); SELL 1.0% (hit 67.8%).</a:t>
+            </a:r>
           </a:p>
           <a:p>
             <a:pPr>
@@ -13641,10 +13290,8 @@
               </a:defRPr>
             </a:pPr>
             <a:r>
-              <a:rPr sz="1400"/>
-              <a:t>• Confusion Matrix: 39,809 TN  |  1,002 FP  |  1,096 FN  |  6,447 TP.</a:t>
-            </a:r>
-            <a:endParaRPr sz="1400"/>
+              <a:t>• Anomaly flags (injected corruptions only): PR-AUC 0.704 vs 0.352 legacy IQR. No real-anomaly accuracy is claimed.</a:t>
+            </a:r>
           </a:p>
         </p:txBody>
       </p:sp>
@@ -13766,7 +13413,7 @@
               </a:defRPr>
             </a:pPr>
             <a:r>
-              <a:t>Real-time streaming results</a:t>
+              <a:t>Streaming and storage results</a:t>
             </a:r>
           </a:p>
         </p:txBody>
@@ -13780,7 +13427,7 @@
         <p:spPr>
           <a:xfrm>
             <a:off x="6464807" y="4133087"/>
-            <a:ext cx="4946903" cy="1941195"/>
+            <a:ext cx="4946903" cy="2057400"/>
           </a:xfrm>
           <a:prstGeom prst="rect">
             <a:avLst/>
@@ -13801,10 +13448,8 @@
               </a:defRPr>
             </a:pPr>
             <a:r>
-              <a:rPr sz="1400"/>
-              <a:t>15,000 real market records replayed through Kafka.</a:t>
-            </a:r>
-            <a:endParaRPr sz="1400"/>
+              <a:t>Replay: 21,524 Kafka messages.</a:t>
+            </a:r>
           </a:p>
           <a:p>
             <a:pPr>
@@ -13818,10 +13463,8 @@
               </a:defRPr>
             </a:pPr>
             <a:r>
-              <a:rPr sz="1400"/>
-              <a:t>• Throughput: Sustained ~1,200 events/sec micro-batch processing.</a:t>
-            </a:r>
-            <a:endParaRPr sz="1400"/>
+              <a:t>• 20,000 to silver + 1,317 duplicates removed + 207 quarantined; 0 missing.</a:t>
+            </a:r>
           </a:p>
           <a:p>
             <a:pPr>
@@ -13835,10 +13478,8 @@
               </a:defRPr>
             </a:pPr>
             <a:r>
-              <a:rPr sz="1400"/>
-              <a:t>• Latency: Sub-800ms micro-batch execution time.</a:t>
-            </a:r>
-            <a:endParaRPr sz="1400"/>
+              <a:t>• Batch/stream parity: 0 mismatches. Producer→sink latency p50: 1.69 s.</a:t>
+            </a:r>
           </a:p>
           <a:p>
             <a:pPr>
@@ -13852,10 +13493,8 @@
               </a:defRPr>
             </a:pPr>
             <a:r>
-              <a:rPr sz="1400"/>
-              <a:t>• Storage: Zero executor memory leaks during continuous Kafka ingestion.</a:t>
-            </a:r>
-            <a:endParaRPr sz="1400"/>
+              <a:t>• Live pull 2026-10-23: 4/4 records through Kafka to silver.</a:t>
+            </a:r>
           </a:p>
           <a:p>
             <a:pPr>
@@ -13869,10 +13508,8 @@
               </a:defRPr>
             </a:pPr>
             <a:r>
-              <a:rPr sz="1400"/>
-              <a:t>• Note: Replay confirms streaming pipeline stability, not ML accuracy.</a:t>
-            </a:r>
-            <a:endParaRPr sz="1400"/>
+              <a:t>• HDFS: 692 MB silver, replication 3, HEALTHY; readable with 1 DataNode down.</a:t>
+            </a:r>
           </a:p>
         </p:txBody>
       </p:sp>
@@ -13885,7 +13522,7 @@
 </file>
 
 <file path=ppt/slides/slide9.xml><?xml version="1.0" encoding="utf-8"?>
-<p:sld xmlns:a="http://schemas.openxmlformats.org/drawingml/2006/main" xmlns:r="http://schemas.openxmlformats.org/officeDocument/2006/relationships" xmlns:p="http://schemas.openxmlformats.org/presentationml/2006/main">
+<p:sld xmlns:a="http://schemas.openxmlformats.org/drawingml/2006/main" xmlns:p="http://schemas.openxmlformats.org/presentationml/2006/main" xmlns:r="http://schemas.openxmlformats.org/officeDocument/2006/relationships">
   <p:cSld>
     <p:spTree>
       <p:nvGrpSpPr>
@@ -13973,7 +13610,7 @@
           </a:fontRef>
         </p:style>
         <p:txBody>
-          <a:bodyPr wrap="square" tIns="73152" rtlCol="0" anchor="ctr"/>
+          <a:bodyPr rtlCol="0" anchor="ctr" wrap="square" tIns="73152"/>
           <a:lstStyle/>
           <a:p>
             <a:pPr algn="ctr">
@@ -14025,7 +13662,7 @@
           </a:fontRef>
         </p:style>
         <p:txBody>
-          <a:bodyPr wrap="square" tIns="73152" rtlCol="0" anchor="ctr"/>
+          <a:bodyPr rtlCol="0" anchor="ctr" wrap="square" tIns="73152"/>
           <a:lstStyle/>
           <a:p>
             <a:pPr algn="ctr">
@@ -14077,7 +13714,7 @@
           </a:fontRef>
         </p:style>
         <p:txBody>
-          <a:bodyPr wrap="square" tIns="73152" rtlCol="0" anchor="ctr"/>
+          <a:bodyPr rtlCol="0" anchor="ctr" wrap="square" tIns="73152"/>
           <a:lstStyle/>
           <a:p>
             <a:pPr algn="ctr">
@@ -14260,7 +13897,7 @@
         <p:spPr>
           <a:xfrm>
             <a:off x="749808" y="1527048"/>
-            <a:ext cx="4946903" cy="1877060"/>
+            <a:ext cx="4946903" cy="2377440"/>
           </a:xfrm>
           <a:prstGeom prst="rect">
             <a:avLst/>
@@ -14281,10 +13918,8 @@
               </a:defRPr>
             </a:pPr>
             <a:r>
-              <a:rPr sz="1400"/>
-              <a:t>• JDK 21 reflection blocked calendar; solved via JVM --add-opens flags.</a:t>
-            </a:r>
-            <a:endParaRPr sz="1400"/>
+              <a:t>• JDK 21 reflection blocked Spark; solved via JVM --add-opens flags.</a:t>
+            </a:r>
           </a:p>
           <a:p>
             <a:pPr>
@@ -14298,10 +13933,8 @@
               </a:defRPr>
             </a:pPr>
             <a:r>
-              <a:rPr sz="1400"/>
-              <a:t>• Date parsing exceptions prevented by coalesce with try_to_date.</a:t>
-            </a:r>
-            <a:endParaRPr sz="1400"/>
+              <a:t>• Malformed dates handled by try_to_date instead of failing jobs.</a:t>
+            </a:r>
           </a:p>
           <a:p>
             <a:pPr>
@@ -14315,10 +13948,8 @@
               </a:defRPr>
             </a:pPr>
             <a:r>
-              <a:rPr sz="1400"/>
-              <a:t>• Full-row distinct() memory OOM resolved by 7-column composite deduplication.</a:t>
-            </a:r>
-            <a:endParaRPr sz="1400"/>
+              <a:t>• Persistence is hard to beat (17–34% zero changes): absolute-loss GBT was needed.</a:t>
+            </a:r>
           </a:p>
           <a:p>
             <a:pPr>
@@ -14332,10 +13963,8 @@
               </a:defRPr>
             </a:pPr>
             <a:r>
-              <a:rPr sz="1400"/>
-              <a:t>• Lineage explosion from recursive windowing truncated via Parquet checkpoints.</a:t>
-            </a:r>
-            <a:endParaRPr sz="1400"/>
+              <a:t>• The archive mirror missed 70% of recent reports; we back-filled official data.</a:t>
+            </a:r>
           </a:p>
         </p:txBody>
       </p:sp>
@@ -14471,7 +14100,7 @@
         <p:spPr>
           <a:xfrm>
             <a:off x="6464807" y="1527048"/>
-            <a:ext cx="4946903" cy="1877060"/>
+            <a:ext cx="4946903" cy="2377440"/>
           </a:xfrm>
           <a:prstGeom prst="rect">
             <a:avLst/>
@@ -14492,10 +14121,8 @@
               </a:defRPr>
             </a:pPr>
             <a:r>
-              <a:rPr sz="1400"/>
-              <a:t>• Local Spark execution (local[*]) rather than multi-node physical YARN cluster.</a:t>
-            </a:r>
-            <a:endParaRPr sz="1400"/>
+              <a:t>• Local Spark (local[*]) and a one-host Docker cluster, not multi-node YARN.</a:t>
+            </a:r>
           </a:p>
           <a:p>
             <a:pPr>
@@ -14509,10 +14136,8 @@
               </a:defRPr>
             </a:pPr>
             <a:r>
-              <a:rPr sz="1400"/>
-              <a:t>• Stream replayed from real historical logs rather than live government REST APIs.</a:t>
-            </a:r>
-            <a:endParaRPr sz="1400"/>
+              <a:t>• HDFS replicas share one disk; single NameNode (no HA).</a:t>
+            </a:r>
           </a:p>
           <a:p>
             <a:pPr>
@@ -14526,10 +14151,8 @@
               </a:defRPr>
             </a:pPr>
             <a:r>
-              <a:rPr sz="1400"/>
-              <a:t>• Automated farmer advisory dispatch (SMS/WhatsApp BUY/SELL engine) is future work.</a:t>
-            </a:r>
-            <a:endParaRPr sz="1400"/>
+              <a:t>• Gains over persistence are modest; per-series smoothing matches us at 1–3 days.</a:t>
+            </a:r>
           </a:p>
           <a:p>
             <a:pPr>
@@ -14543,10 +14166,8 @@
               </a:defRPr>
             </a:pPr>
             <a:r>
-              <a:rPr sz="1400"/>
-              <a:t>• Future: Deploy to AWS EMR and train deep LSTM multi-step price forecasting.</a:t>
-            </a:r>
-            <a:endParaRPr sz="1400"/>
+              <a:t>• No public deployment yet; decision-card hit rates are not farm profits.</a:t>
+            </a:r>
           </a:p>
         </p:txBody>
       </p:sp>
@@ -14668,7 +14289,7 @@
               </a:defRPr>
             </a:pPr>
             <a:r>
-              <a:t>Did 7-column composite deduplication outperform full-row distinct()?</a:t>
+              <a:t>What changed since v1, and why?</a:t>
             </a:r>
           </a:p>
         </p:txBody>
@@ -14682,7 +14303,7 @@
         <p:spPr>
           <a:xfrm>
             <a:off x="777240" y="4599431"/>
-            <a:ext cx="10607040" cy="738505"/>
+            <a:ext cx="10607040" cy="813815"/>
           </a:xfrm>
           <a:prstGeom prst="rect">
             <a:avLst/>
@@ -14703,10 +14324,8 @@
               </a:defRPr>
             </a:pPr>
             <a:r>
-              <a:rPr sz="1600"/>
-              <a:t>Yes. Full-row distinct() hashes all 10 columns across 133 million rows, causing severe shuffle skew and OutOfMemoryError. Partitioning by a 7-column composite business key with row_number() enabled map-side partial reduction, completing cleanly in 4.2 minutes with zero memory spills.</a:t>
-            </a:r>
-            <a:endParaRPr sz="1600"/>
+              <a:t>v1 reported an anomaly classifier with very high accuracy and Kafka throughput/latency figures. No code or log produces them, the v1 labels were functions of the features, and its bounds were fitted on test years, so they are withdrawn (docs/AUDIT_PRIOR_RESULTS.md). The project now leads with an honestly evaluated forecasting benchmark.</a:t>
+            </a:r>
           </a:p>
         </p:txBody>
       </p:sp>
@@ -14719,7 +14338,7 @@
         <p:spPr>
           <a:xfrm>
             <a:off x="548640" y="5623560"/>
-            <a:ext cx="11118850" cy="306705"/>
+            <a:ext cx="11064240" cy="365760"/>
           </a:xfrm>
           <a:prstGeom prst="rect">
             <a:avLst/>
@@ -14740,10 +14359,8 @@
               </a:defRPr>
             </a:pPr>
             <a:r>
-              <a:rPr sz="1400"/>
-              <a:t>Conclusion: the system processes 132.9M real rows, maintains HDFS replication, and produces 95.66% accurate real-time alerts.</a:t>
-            </a:r>
-            <a:endParaRPr sz="1400"/>
+              <a:t>Conclusion: 3–8% lower error than persistence at all horizons, calibrated 80% intervals, gains that hold on six unseen months.</a:t>
+            </a:r>
           </a:p>
         </p:txBody>
       </p:sp>
@@ -15071,11 +14688,7 @@
       </a:style>
     </a:lnDef>
   </a:objectDefaults>
-  <a:extLst>
-    <a:ext uri="{05A4C25C-085E-4340-85A3-A5531E510DB2}">
-      <thm15:themeFamily xmlns:thm15="http://schemas.microsoft.com/office/thememl/2012/main" name="Office Theme" id="{62F939B6-93AF-4DB8-9C6B-D6C7DFDC589F}" vid="{4A3C46E8-61CC-4603-A589-7422A47A8E4A}"/>
-    </a:ext>
-  </a:extLst>
+  <a:extraClrSchemeLst/>
 </a:theme>
 </file>
 
@@ -15395,10 +15008,6 @@
       </a:style>
     </a:lnDef>
   </a:objectDefaults>
-  <a:extLst>
-    <a:ext uri="{05A4C25C-085E-4340-85A3-A5531E510DB2}">
-      <thm15:themeFamily xmlns:thm15="http://schemas.microsoft.com/office/thememl/2012/main" name="Office Theme" id="{62F939B6-93AF-4DB8-9C6B-D6C7DFDC589F}" vid="{4A3C46E8-61CC-4603-A589-7422A47A8E4A}"/>
-    </a:ext>
-  </a:extLst>
+  <a:extraClrSchemeLst/>
 </a:theme>
 </file>
</xml_diff>